<commit_message>
docs: pitch deck v3.1 — add MP 1304 repricing narrative to ACL slides
</commit_message>
<xml_diff>
--- a/docs/Solar_BESS_Platform_PitchDeck.pptx
+++ b/docs/Solar_BESS_Platform_PitchDeck.pptx
@@ -29272,7 +29272,7 @@
                   <a:srgbClr val="FFFFFF"/>
                 </a:solidFill>
               </a:rPr>
-              <a:t>EXPANSÃO DO ACL</a:t>
+              <a:t>ACL + MP 1304</a:t>
             </a:r>
           </a:p>
         </p:txBody>
@@ -29306,7 +29306,7 @@
                   <a:srgbClr val="CCD6E8"/>
                 </a:solidFill>
               </a:rPr>
-              <a:t>▸  300.000 empresas migrarão do mercado regulado (ACR) para o livre (ACL) até 2028</a:t>
+              <a:t>▸  300.000 empresas migrarão para o ACL até 2028 (volume)</a:t>
             </a:r>
           </a:p>
         </p:txBody>
@@ -29340,7 +29340,7 @@
                   <a:srgbClr val="CCD6E8"/>
                 </a:solidFill>
               </a:rPr>
-              <a:t>▸  Exposição à volatilidade de preço — sem hedge</a:t>
+              <a:t>▸  MP 1304 criou repricing imediato: preços sobem AGORA para quem já está no ACL</a:t>
             </a:r>
           </a:p>
         </p:txBody>
@@ -29374,7 +29374,7 @@
                   <a:srgbClr val="CCD6E8"/>
                 </a:solidFill>
               </a:rPr>
-              <a:t>▸  PLD pode variar de R$ 0 a R$ 2.000/MWh</a:t>
+              <a:t>▸  PLD pode variar de R$ 0 a R$ 2.000/MWh — sem teto efetivo</a:t>
             </a:r>
           </a:p>
         </p:txBody>
@@ -29408,7 +29408,7 @@
                   <a:srgbClr val="CCD6E8"/>
                 </a:solidFill>
               </a:rPr>
-              <a:t>▸  Janela de decisão energética: 2026–2028</a:t>
+              <a:t>▸  Efeito duplo: quem migrou sente a dor; quem vai migrar vê o futuro</a:t>
             </a:r>
           </a:p>
         </p:txBody>
@@ -29991,7 +29991,7 @@
                   <a:srgbClr val="FFFFFF"/>
                 </a:solidFill>
               </a:rPr>
-              <a:t>Choque 1: Expansão do ACL</a:t>
+              <a:t>Choque 1: ACL — Migração + Repricing pelo MP 1304</a:t>
             </a:r>
           </a:p>
         </p:txBody>
@@ -30025,7 +30025,7 @@
                   <a:srgbClr val="00C8FF"/>
                 </a:solidFill>
               </a:rPr>
-              <a:t>O maior realinhamento de preços de energia da história do Brasil</a:t>
+              <a:t>Não é só quem vai migrar: quem já está no mercado livre sente a pressão agora</a:t>
             </a:r>
           </a:p>
         </p:txBody>
@@ -30081,8 +30081,8 @@
         </p:nvSpPr>
         <p:spPr>
           <a:xfrm>
-            <a:off x="457200" y="1417320"/>
-            <a:ext cx="2286000" cy="1005840"/>
+            <a:off x="365760" y="1371600"/>
+            <a:ext cx="5577840" cy="2148840"/>
           </a:xfrm>
           <a:prstGeom prst="rect">
             <a:avLst/>
@@ -30126,119 +30126,50 @@
         </p:nvSpPr>
         <p:spPr>
           <a:xfrm>
-            <a:off x="548640" y="1481328"/>
-            <a:ext cx="2103120" cy="411480"/>
-          </a:xfrm>
-          <a:prstGeom prst="rect">
-            <a:avLst/>
-          </a:prstGeom>
-          <a:noFill/>
-        </p:spPr>
-        <p:txBody>
-          <a:bodyPr wrap="square">
-            <a:spAutoFit/>
-          </a:bodyPr>
-          <a:lstStyle/>
-          <a:p>
-            <a:pPr algn="ctr"/>
-            <a:r>
-              <a:rPr sz="1600" b="1" i="0">
+            <a:off x="548640" y="1435608"/>
+            <a:ext cx="5212080" cy="347472"/>
+          </a:xfrm>
+          <a:prstGeom prst="rect">
+            <a:avLst/>
+          </a:prstGeom>
+          <a:noFill/>
+        </p:spPr>
+        <p:txBody>
+          <a:bodyPr wrap="square">
+            <a:spAutoFit/>
+          </a:bodyPr>
+          <a:lstStyle/>
+          <a:p>
+            <a:pPr algn="l"/>
+            <a:r>
+              <a:rPr sz="1200" b="1" i="0">
                 <a:solidFill>
                   <a:srgbClr val="00C8FF"/>
                 </a:solidFill>
               </a:rPr>
-              <a:t>Antes
-2024</a:t>
-            </a:r>
-          </a:p>
-        </p:txBody>
-      </p:sp>
-      <p:sp>
-        <p:nvSpPr>
-          <p:cNvPr id="8" name="TextBox 7"/>
-          <p:cNvSpPr txBox="1"/>
+              <a:t>VETOR 1 — VOLUME DE MIGRAÇÃO</a:t>
+            </a:r>
+          </a:p>
+        </p:txBody>
+      </p:sp>
+      <p:sp>
+        <p:nvSpPr>
+          <p:cNvPr id="8" name="Rectangle 7"/>
+          <p:cNvSpPr/>
           <p:nvPr/>
         </p:nvSpPr>
         <p:spPr>
           <a:xfrm>
             <a:off x="548640" y="1874519"/>
-            <a:ext cx="2103120" cy="502920"/>
-          </a:xfrm>
-          <a:prstGeom prst="rect">
-            <a:avLst/>
-          </a:prstGeom>
-          <a:noFill/>
-        </p:spPr>
-        <p:txBody>
-          <a:bodyPr wrap="square">
-            <a:spAutoFit/>
-          </a:bodyPr>
-          <a:lstStyle/>
-          <a:p>
-            <a:pPr algn="ctr"/>
-            <a:r>
-              <a:rPr sz="1100" b="0" i="0">
-                <a:solidFill>
-                  <a:srgbClr val="FFFFFF"/>
-                </a:solidFill>
-              </a:rPr>
-              <a:t>Apenas &gt;1,5 MW</a:t>
-            </a:r>
-          </a:p>
-        </p:txBody>
-      </p:sp>
-      <p:sp>
-        <p:nvSpPr>
-          <p:cNvPr id="9" name="TextBox 8"/>
-          <p:cNvSpPr txBox="1"/>
-          <p:nvPr/>
-        </p:nvSpPr>
-        <p:spPr>
-          <a:xfrm>
-            <a:off x="2788920" y="1691640"/>
-            <a:ext cx="457200" cy="365760"/>
-          </a:xfrm>
-          <a:prstGeom prst="rect">
-            <a:avLst/>
-          </a:prstGeom>
-          <a:noFill/>
-        </p:spPr>
-        <p:txBody>
-          <a:bodyPr wrap="square">
-            <a:spAutoFit/>
-          </a:bodyPr>
-          <a:lstStyle/>
-          <a:p>
-            <a:pPr algn="ctr"/>
-            <a:r>
-              <a:rPr sz="2000" b="1" i="0">
-                <a:solidFill>
-                  <a:srgbClr val="8AA0C0"/>
-                </a:solidFill>
-              </a:rPr>
-              <a:t>→</a:t>
-            </a:r>
-          </a:p>
-        </p:txBody>
-      </p:sp>
-      <p:sp>
-        <p:nvSpPr>
-          <p:cNvPr id="10" name="Rectangle 9"/>
-          <p:cNvSpPr/>
-          <p:nvPr/>
-        </p:nvSpPr>
-        <p:spPr>
-          <a:xfrm>
-            <a:off x="3291840" y="1417320"/>
-            <a:ext cx="2286000" cy="1005840"/>
-          </a:xfrm>
-          <a:prstGeom prst="rect">
-            <a:avLst/>
-          </a:prstGeom>
-          <a:solidFill>
-            <a:srgbClr val="1E355A"/>
-          </a:solidFill>
-          <a:ln w="19050">
+            <a:ext cx="1508760" cy="731520"/>
+          </a:xfrm>
+          <a:prstGeom prst="rect">
+            <a:avLst/>
+          </a:prstGeom>
+          <a:solidFill>
+            <a:srgbClr val="102A50"/>
+          </a:solidFill>
+          <a:ln w="10160">
             <a:solidFill>
               <a:srgbClr val="00C8FF"/>
             </a:solidFill>
@@ -30268,97 +30199,97 @@
       </p:sp>
       <p:sp>
         <p:nvSpPr>
+          <p:cNvPr id="9" name="TextBox 8"/>
+          <p:cNvSpPr txBox="1"/>
+          <p:nvPr/>
+        </p:nvSpPr>
+        <p:spPr>
+          <a:xfrm>
+            <a:off x="621792" y="1920240"/>
+            <a:ext cx="1371600" cy="320040"/>
+          </a:xfrm>
+          <a:prstGeom prst="rect">
+            <a:avLst/>
+          </a:prstGeom>
+          <a:noFill/>
+        </p:spPr>
+        <p:txBody>
+          <a:bodyPr wrap="square">
+            <a:spAutoFit/>
+          </a:bodyPr>
+          <a:lstStyle/>
+          <a:p>
+            <a:pPr algn="ctr"/>
+            <a:r>
+              <a:rPr sz="1300" b="1" i="0">
+                <a:solidFill>
+                  <a:srgbClr val="00C8FF"/>
+                </a:solidFill>
+              </a:rPr>
+              <a:t>2024</a:t>
+            </a:r>
+          </a:p>
+        </p:txBody>
+      </p:sp>
+      <p:sp>
+        <p:nvSpPr>
+          <p:cNvPr id="10" name="TextBox 9"/>
+          <p:cNvSpPr txBox="1"/>
+          <p:nvPr/>
+        </p:nvSpPr>
+        <p:spPr>
+          <a:xfrm>
+            <a:off x="621792" y="2240280"/>
+            <a:ext cx="1371600" cy="320040"/>
+          </a:xfrm>
+          <a:prstGeom prst="rect">
+            <a:avLst/>
+          </a:prstGeom>
+          <a:noFill/>
+        </p:spPr>
+        <p:txBody>
+          <a:bodyPr wrap="square">
+            <a:spAutoFit/>
+          </a:bodyPr>
+          <a:lstStyle/>
+          <a:p>
+            <a:pPr algn="ctr"/>
+            <a:r>
+              <a:rPr sz="1100" b="0" i="0">
+                <a:solidFill>
+                  <a:srgbClr val="FFFFFF"/>
+                </a:solidFill>
+              </a:rPr>
+              <a:t>&gt;1 MW</a:t>
+            </a:r>
+          </a:p>
+        </p:txBody>
+      </p:sp>
+      <p:sp>
+        <p:nvSpPr>
           <p:cNvPr id="11" name="TextBox 10"/>
           <p:cNvSpPr txBox="1"/>
           <p:nvPr/>
         </p:nvSpPr>
         <p:spPr>
           <a:xfrm>
-            <a:off x="3383280" y="1481328"/>
-            <a:ext cx="2103120" cy="411480"/>
-          </a:xfrm>
-          <a:prstGeom prst="rect">
-            <a:avLst/>
-          </a:prstGeom>
-          <a:noFill/>
-        </p:spPr>
-        <p:txBody>
-          <a:bodyPr wrap="square">
-            <a:spAutoFit/>
-          </a:bodyPr>
-          <a:lstStyle/>
-          <a:p>
-            <a:pPr algn="ctr"/>
-            <a:r>
-              <a:rPr sz="1600" b="1" i="0">
-                <a:solidFill>
-                  <a:srgbClr val="00C8FF"/>
-                </a:solidFill>
-              </a:rPr>
-              <a:t>2024</a:t>
-            </a:r>
-          </a:p>
-        </p:txBody>
-      </p:sp>
-      <p:sp>
-        <p:nvSpPr>
-          <p:cNvPr id="12" name="TextBox 11"/>
-          <p:cNvSpPr txBox="1"/>
-          <p:nvPr/>
-        </p:nvSpPr>
-        <p:spPr>
-          <a:xfrm>
-            <a:off x="3383280" y="1874519"/>
-            <a:ext cx="2103120" cy="502920"/>
-          </a:xfrm>
-          <a:prstGeom prst="rect">
-            <a:avLst/>
-          </a:prstGeom>
-          <a:noFill/>
-        </p:spPr>
-        <p:txBody>
-          <a:bodyPr wrap="square">
-            <a:spAutoFit/>
-          </a:bodyPr>
-          <a:lstStyle/>
-          <a:p>
-            <a:pPr algn="ctr"/>
-            <a:r>
-              <a:rPr sz="1100" b="0" i="0">
-                <a:solidFill>
-                  <a:srgbClr val="FFFFFF"/>
-                </a:solidFill>
-              </a:rPr>
-              <a:t>&gt; 1,0 MW</a:t>
-            </a:r>
-          </a:p>
-        </p:txBody>
-      </p:sp>
-      <p:sp>
-        <p:nvSpPr>
-          <p:cNvPr id="13" name="TextBox 12"/>
-          <p:cNvSpPr txBox="1"/>
-          <p:nvPr/>
-        </p:nvSpPr>
-        <p:spPr>
-          <a:xfrm>
-            <a:off x="5623560" y="1691640"/>
-            <a:ext cx="457200" cy="365760"/>
-          </a:xfrm>
-          <a:prstGeom prst="rect">
-            <a:avLst/>
-          </a:prstGeom>
-          <a:noFill/>
-        </p:spPr>
-        <p:txBody>
-          <a:bodyPr wrap="square">
-            <a:spAutoFit/>
-          </a:bodyPr>
-          <a:lstStyle/>
-          <a:p>
-            <a:pPr algn="ctr"/>
-            <a:r>
-              <a:rPr sz="2000" b="1" i="0">
+            <a:off x="2084831" y="2103120"/>
+            <a:ext cx="182880" cy="274320"/>
+          </a:xfrm>
+          <a:prstGeom prst="rect">
+            <a:avLst/>
+          </a:prstGeom>
+          <a:noFill/>
+        </p:spPr>
+        <p:txBody>
+          <a:bodyPr wrap="square">
+            <a:spAutoFit/>
+          </a:bodyPr>
+          <a:lstStyle/>
+          <a:p>
+            <a:pPr algn="ctr"/>
+            <a:r>
+              <a:rPr sz="1400" b="0" i="0">
                 <a:solidFill>
                   <a:srgbClr val="8AA0C0"/>
                 </a:solidFill>
@@ -30370,22 +30301,22 @@
       </p:sp>
       <p:sp>
         <p:nvSpPr>
-          <p:cNvPr id="14" name="Rectangle 13"/>
+          <p:cNvPr id="12" name="Rectangle 11"/>
           <p:cNvSpPr/>
           <p:nvPr/>
         </p:nvSpPr>
         <p:spPr>
           <a:xfrm>
-            <a:off x="6126480" y="1417320"/>
-            <a:ext cx="2286000" cy="1005840"/>
-          </a:xfrm>
-          <a:prstGeom prst="rect">
-            <a:avLst/>
-          </a:prstGeom>
-          <a:solidFill>
-            <a:srgbClr val="1E355A"/>
-          </a:solidFill>
-          <a:ln w="19050">
+            <a:off x="2304288" y="1874519"/>
+            <a:ext cx="1508760" cy="731520"/>
+          </a:xfrm>
+          <a:prstGeom prst="rect">
+            <a:avLst/>
+          </a:prstGeom>
+          <a:solidFill>
+            <a:srgbClr val="102A50"/>
+          </a:solidFill>
+          <a:ln w="10160">
             <a:solidFill>
               <a:srgbClr val="00C8FF"/>
             </a:solidFill>
@@ -30415,97 +30346,97 @@
       </p:sp>
       <p:sp>
         <p:nvSpPr>
+          <p:cNvPr id="13" name="TextBox 12"/>
+          <p:cNvSpPr txBox="1"/>
+          <p:nvPr/>
+        </p:nvSpPr>
+        <p:spPr>
+          <a:xfrm>
+            <a:off x="2377440" y="1920240"/>
+            <a:ext cx="1371600" cy="320040"/>
+          </a:xfrm>
+          <a:prstGeom prst="rect">
+            <a:avLst/>
+          </a:prstGeom>
+          <a:noFill/>
+        </p:spPr>
+        <p:txBody>
+          <a:bodyPr wrap="square">
+            <a:spAutoFit/>
+          </a:bodyPr>
+          <a:lstStyle/>
+          <a:p>
+            <a:pPr algn="ctr"/>
+            <a:r>
+              <a:rPr sz="1300" b="1" i="0">
+                <a:solidFill>
+                  <a:srgbClr val="00C8FF"/>
+                </a:solidFill>
+              </a:rPr>
+              <a:t>2026</a:t>
+            </a:r>
+          </a:p>
+        </p:txBody>
+      </p:sp>
+      <p:sp>
+        <p:nvSpPr>
+          <p:cNvPr id="14" name="TextBox 13"/>
+          <p:cNvSpPr txBox="1"/>
+          <p:nvPr/>
+        </p:nvSpPr>
+        <p:spPr>
+          <a:xfrm>
+            <a:off x="2377440" y="2240280"/>
+            <a:ext cx="1371600" cy="320040"/>
+          </a:xfrm>
+          <a:prstGeom prst="rect">
+            <a:avLst/>
+          </a:prstGeom>
+          <a:noFill/>
+        </p:spPr>
+        <p:txBody>
+          <a:bodyPr wrap="square">
+            <a:spAutoFit/>
+          </a:bodyPr>
+          <a:lstStyle/>
+          <a:p>
+            <a:pPr algn="ctr"/>
+            <a:r>
+              <a:rPr sz="1100" b="0" i="0">
+                <a:solidFill>
+                  <a:srgbClr val="FFFFFF"/>
+                </a:solidFill>
+              </a:rPr>
+              <a:t>&gt;500 kW</a:t>
+            </a:r>
+          </a:p>
+        </p:txBody>
+      </p:sp>
+      <p:sp>
+        <p:nvSpPr>
           <p:cNvPr id="15" name="TextBox 14"/>
           <p:cNvSpPr txBox="1"/>
           <p:nvPr/>
         </p:nvSpPr>
         <p:spPr>
           <a:xfrm>
-            <a:off x="6217920" y="1481328"/>
-            <a:ext cx="2103120" cy="411480"/>
-          </a:xfrm>
-          <a:prstGeom prst="rect">
-            <a:avLst/>
-          </a:prstGeom>
-          <a:noFill/>
-        </p:spPr>
-        <p:txBody>
-          <a:bodyPr wrap="square">
-            <a:spAutoFit/>
-          </a:bodyPr>
-          <a:lstStyle/>
-          <a:p>
-            <a:pPr algn="ctr"/>
-            <a:r>
-              <a:rPr sz="1600" b="1" i="0">
-                <a:solidFill>
-                  <a:srgbClr val="00C8FF"/>
-                </a:solidFill>
-              </a:rPr>
-              <a:t>2026</a:t>
-            </a:r>
-          </a:p>
-        </p:txBody>
-      </p:sp>
-      <p:sp>
-        <p:nvSpPr>
-          <p:cNvPr id="16" name="TextBox 15"/>
-          <p:cNvSpPr txBox="1"/>
-          <p:nvPr/>
-        </p:nvSpPr>
-        <p:spPr>
-          <a:xfrm>
-            <a:off x="6217920" y="1874519"/>
-            <a:ext cx="2103120" cy="502920"/>
-          </a:xfrm>
-          <a:prstGeom prst="rect">
-            <a:avLst/>
-          </a:prstGeom>
-          <a:noFill/>
-        </p:spPr>
-        <p:txBody>
-          <a:bodyPr wrap="square">
-            <a:spAutoFit/>
-          </a:bodyPr>
-          <a:lstStyle/>
-          <a:p>
-            <a:pPr algn="ctr"/>
-            <a:r>
-              <a:rPr sz="1100" b="0" i="0">
-                <a:solidFill>
-                  <a:srgbClr val="FFFFFF"/>
-                </a:solidFill>
-              </a:rPr>
-              <a:t>&gt; 500 kW</a:t>
-            </a:r>
-          </a:p>
-        </p:txBody>
-      </p:sp>
-      <p:sp>
-        <p:nvSpPr>
-          <p:cNvPr id="17" name="TextBox 16"/>
-          <p:cNvSpPr txBox="1"/>
-          <p:nvPr/>
-        </p:nvSpPr>
-        <p:spPr>
-          <a:xfrm>
-            <a:off x="8458200" y="1691640"/>
-            <a:ext cx="457200" cy="365760"/>
-          </a:xfrm>
-          <a:prstGeom prst="rect">
-            <a:avLst/>
-          </a:prstGeom>
-          <a:noFill/>
-        </p:spPr>
-        <p:txBody>
-          <a:bodyPr wrap="square">
-            <a:spAutoFit/>
-          </a:bodyPr>
-          <a:lstStyle/>
-          <a:p>
-            <a:pPr algn="ctr"/>
-            <a:r>
-              <a:rPr sz="2000" b="1" i="0">
+            <a:off x="3840480" y="2103120"/>
+            <a:ext cx="182880" cy="274320"/>
+          </a:xfrm>
+          <a:prstGeom prst="rect">
+            <a:avLst/>
+          </a:prstGeom>
+          <a:noFill/>
+        </p:spPr>
+        <p:txBody>
+          <a:bodyPr wrap="square">
+            <a:spAutoFit/>
+          </a:bodyPr>
+          <a:lstStyle/>
+          <a:p>
+            <a:pPr algn="ctr"/>
+            <a:r>
+              <a:rPr sz="1400" b="0" i="0">
                 <a:solidFill>
                   <a:srgbClr val="8AA0C0"/>
                 </a:solidFill>
@@ -30517,24 +30448,24 @@
       </p:sp>
       <p:sp>
         <p:nvSpPr>
-          <p:cNvPr id="18" name="Rectangle 17"/>
+          <p:cNvPr id="16" name="Rectangle 15"/>
           <p:cNvSpPr/>
           <p:nvPr/>
         </p:nvSpPr>
         <p:spPr>
           <a:xfrm>
-            <a:off x="8961120" y="1417320"/>
-            <a:ext cx="2286000" cy="1005840"/>
-          </a:xfrm>
-          <a:prstGeom prst="rect">
-            <a:avLst/>
-          </a:prstGeom>
-          <a:solidFill>
-            <a:srgbClr val="1E355A"/>
-          </a:solidFill>
-          <a:ln w="19050">
+            <a:off x="4059935" y="1874519"/>
+            <a:ext cx="1508760" cy="731520"/>
+          </a:xfrm>
+          <a:prstGeom prst="rect">
+            <a:avLst/>
+          </a:prstGeom>
+          <a:solidFill>
+            <a:srgbClr val="102A50"/>
+          </a:solidFill>
+          <a:ln w="10160">
             <a:solidFill>
-              <a:srgbClr val="FF8C00"/>
+              <a:srgbClr val="00C8FF"/>
             </a:solidFill>
           </a:ln>
         </p:spPr>
@@ -30562,126 +30493,127 @@
       </p:sp>
       <p:sp>
         <p:nvSpPr>
+          <p:cNvPr id="17" name="TextBox 16"/>
+          <p:cNvSpPr txBox="1"/>
+          <p:nvPr/>
+        </p:nvSpPr>
+        <p:spPr>
+          <a:xfrm>
+            <a:off x="4133087" y="1920240"/>
+            <a:ext cx="1371600" cy="320040"/>
+          </a:xfrm>
+          <a:prstGeom prst="rect">
+            <a:avLst/>
+          </a:prstGeom>
+          <a:noFill/>
+        </p:spPr>
+        <p:txBody>
+          <a:bodyPr wrap="square">
+            <a:spAutoFit/>
+          </a:bodyPr>
+          <a:lstStyle/>
+          <a:p>
+            <a:pPr algn="ctr"/>
+            <a:r>
+              <a:rPr sz="1300" b="1" i="0">
+                <a:solidFill>
+                  <a:srgbClr val="00C8FF"/>
+                </a:solidFill>
+              </a:rPr>
+              <a:t>2028</a:t>
+            </a:r>
+          </a:p>
+        </p:txBody>
+      </p:sp>
+      <p:sp>
+        <p:nvSpPr>
+          <p:cNvPr id="18" name="TextBox 17"/>
+          <p:cNvSpPr txBox="1"/>
+          <p:nvPr/>
+        </p:nvSpPr>
+        <p:spPr>
+          <a:xfrm>
+            <a:off x="4133087" y="2240280"/>
+            <a:ext cx="1371600" cy="320040"/>
+          </a:xfrm>
+          <a:prstGeom prst="rect">
+            <a:avLst/>
+          </a:prstGeom>
+          <a:noFill/>
+        </p:spPr>
+        <p:txBody>
+          <a:bodyPr wrap="square">
+            <a:spAutoFit/>
+          </a:bodyPr>
+          <a:lstStyle/>
+          <a:p>
+            <a:pPr algn="ctr"/>
+            <a:r>
+              <a:rPr sz="1100" b="0" i="0">
+                <a:solidFill>
+                  <a:srgbClr val="FFFFFF"/>
+                </a:solidFill>
+              </a:rPr>
+              <a:t>TODOS</a:t>
+            </a:r>
+          </a:p>
+        </p:txBody>
+      </p:sp>
+      <p:sp>
+        <p:nvSpPr>
           <p:cNvPr id="19" name="TextBox 18"/>
           <p:cNvSpPr txBox="1"/>
           <p:nvPr/>
         </p:nvSpPr>
         <p:spPr>
           <a:xfrm>
-            <a:off x="9052560" y="1481328"/>
-            <a:ext cx="2103120" cy="411480"/>
-          </a:xfrm>
-          <a:prstGeom prst="rect">
-            <a:avLst/>
-          </a:prstGeom>
-          <a:noFill/>
-        </p:spPr>
-        <p:txBody>
-          <a:bodyPr wrap="square">
-            <a:spAutoFit/>
-          </a:bodyPr>
-          <a:lstStyle/>
-          <a:p>
-            <a:pPr algn="ctr"/>
-            <a:r>
-              <a:rPr sz="1600" b="1" i="0">
-                <a:solidFill>
-                  <a:srgbClr val="FF8C00"/>
-                </a:solidFill>
-              </a:rPr>
-              <a:t>2028</a:t>
-            </a:r>
-          </a:p>
-        </p:txBody>
-      </p:sp>
-      <p:sp>
-        <p:nvSpPr>
-          <p:cNvPr id="20" name="TextBox 19"/>
-          <p:cNvSpPr txBox="1"/>
-          <p:nvPr/>
-        </p:nvSpPr>
-        <p:spPr>
-          <a:xfrm>
-            <a:off x="9052560" y="1874519"/>
-            <a:ext cx="2103120" cy="502920"/>
-          </a:xfrm>
-          <a:prstGeom prst="rect">
-            <a:avLst/>
-          </a:prstGeom>
-          <a:noFill/>
-        </p:spPr>
-        <p:txBody>
-          <a:bodyPr wrap="square">
-            <a:spAutoFit/>
-          </a:bodyPr>
-          <a:lstStyle/>
-          <a:p>
-            <a:pPr algn="ctr"/>
-            <a:r>
-              <a:rPr sz="1100" b="0" i="0">
-                <a:solidFill>
-                  <a:srgbClr val="FFFFFF"/>
-                </a:solidFill>
-              </a:rPr>
-              <a:t>TODOS em
-média tensão</a:t>
-            </a:r>
-          </a:p>
-        </p:txBody>
-      </p:sp>
-      <p:sp>
-        <p:nvSpPr>
-          <p:cNvPr id="21" name="TextBox 20"/>
-          <p:cNvSpPr txBox="1"/>
-          <p:nvPr/>
-        </p:nvSpPr>
-        <p:spPr>
-          <a:xfrm>
-            <a:off x="457200" y="2606040"/>
-            <a:ext cx="11247120" cy="365760"/>
-          </a:xfrm>
-          <a:prstGeom prst="rect">
-            <a:avLst/>
-          </a:prstGeom>
-          <a:noFill/>
-        </p:spPr>
-        <p:txBody>
-          <a:bodyPr wrap="square">
-            <a:spAutoFit/>
-          </a:bodyPr>
-          <a:lstStyle/>
-          <a:p>
-            <a:pPr algn="ctr"/>
-            <a:r>
-              <a:rPr sz="1400" b="1" i="0">
+            <a:off x="548640" y="2697480"/>
+            <a:ext cx="5212080" cy="292608"/>
+          </a:xfrm>
+          <a:prstGeom prst="rect">
+            <a:avLst/>
+          </a:prstGeom>
+          <a:noFill/>
+        </p:spPr>
+        <p:txBody>
+          <a:bodyPr wrap="square">
+            <a:spAutoFit/>
+          </a:bodyPr>
+          <a:lstStyle/>
+          <a:p>
+            <a:pPr algn="l"/>
+            <a:r>
+              <a:rPr sz="1100" b="0" i="1">
                 <a:solidFill>
                   <a:srgbClr val="FFD600"/>
                 </a:solidFill>
               </a:rPr>
-              <a:t>300.000+ empresas passarão do ACR para o ACL até 2028</a:t>
-            </a:r>
-          </a:p>
-        </p:txBody>
-      </p:sp>
-      <p:sp>
-        <p:nvSpPr>
-          <p:cNvPr id="22" name="Rectangle 21"/>
+              <a:t>300.000+ empresas buscando hedge até 2028</a:t>
+            </a:r>
+          </a:p>
+        </p:txBody>
+      </p:sp>
+      <p:sp>
+        <p:nvSpPr>
+          <p:cNvPr id="20" name="Rectangle 19"/>
           <p:cNvSpPr/>
           <p:nvPr/>
         </p:nvSpPr>
         <p:spPr>
           <a:xfrm>
-            <a:off x="457200" y="3063240"/>
-            <a:ext cx="2926080" cy="384048"/>
-          </a:xfrm>
-          <a:prstGeom prst="rect">
-            <a:avLst/>
-          </a:prstGeom>
-          <a:solidFill>
-            <a:srgbClr val="FF8C00"/>
-          </a:solidFill>
-          <a:ln>
-            <a:noFill/>
+            <a:off x="6309360" y="1371600"/>
+            <a:ext cx="5486400" cy="2148840"/>
+          </a:xfrm>
+          <a:prstGeom prst="rect">
+            <a:avLst/>
+          </a:prstGeom>
+          <a:solidFill>
+            <a:srgbClr val="1E355A"/>
+          </a:solidFill>
+          <a:ln w="25400">
+            <a:solidFill>
+              <a:srgbClr val="FF8C00"/>
+            </a:solidFill>
           </a:ln>
         </p:spPr>
         <p:style>
@@ -30708,48 +30640,252 @@
       </p:sp>
       <p:sp>
         <p:nvSpPr>
+          <p:cNvPr id="21" name="TextBox 20"/>
+          <p:cNvSpPr txBox="1"/>
+          <p:nvPr/>
+        </p:nvSpPr>
+        <p:spPr>
+          <a:xfrm>
+            <a:off x="6492240" y="1435608"/>
+            <a:ext cx="5120640" cy="347472"/>
+          </a:xfrm>
+          <a:prstGeom prst="rect">
+            <a:avLst/>
+          </a:prstGeom>
+          <a:noFill/>
+        </p:spPr>
+        <p:txBody>
+          <a:bodyPr wrap="square">
+            <a:spAutoFit/>
+          </a:bodyPr>
+          <a:lstStyle/>
+          <a:p>
+            <a:pPr algn="l"/>
+            <a:r>
+              <a:rPr sz="1200" b="1" i="0">
+                <a:solidFill>
+                  <a:srgbClr val="FF8C00"/>
+                </a:solidFill>
+              </a:rPr>
+              <a:t>VETOR 2 — MP 1304: REPRICING IMEDIATO</a:t>
+            </a:r>
+          </a:p>
+        </p:txBody>
+      </p:sp>
+      <p:sp>
+        <p:nvSpPr>
+          <p:cNvPr id="22" name="TextBox 21"/>
+          <p:cNvSpPr txBox="1"/>
+          <p:nvPr/>
+        </p:nvSpPr>
+        <p:spPr>
+          <a:xfrm>
+            <a:off x="6492240" y="1892807"/>
+            <a:ext cx="5120640" cy="320040"/>
+          </a:xfrm>
+          <a:prstGeom prst="rect">
+            <a:avLst/>
+          </a:prstGeom>
+          <a:noFill/>
+        </p:spPr>
+        <p:txBody>
+          <a:bodyPr wrap="square">
+            <a:spAutoFit/>
+          </a:bodyPr>
+          <a:lstStyle/>
+          <a:p>
+            <a:pPr algn="l"/>
+            <a:r>
+              <a:rPr sz="1100" b="0" i="0">
+                <a:solidFill>
+                  <a:srgbClr val="CCD6E8"/>
+                </a:solidFill>
+              </a:rPr>
+              <a:t>Mudou a mecânica de precificação do ACL:</a:t>
+            </a:r>
+          </a:p>
+        </p:txBody>
+      </p:sp>
+      <p:sp>
+        <p:nvSpPr>
           <p:cNvPr id="23" name="TextBox 22"/>
           <p:cNvSpPr txBox="1"/>
           <p:nvPr/>
         </p:nvSpPr>
         <p:spPr>
           <a:xfrm>
-            <a:off x="512064" y="3118104"/>
-            <a:ext cx="2816352" cy="292607"/>
-          </a:xfrm>
-          <a:prstGeom prst="rect">
-            <a:avLst/>
-          </a:prstGeom>
-          <a:noFill/>
-        </p:spPr>
-        <p:txBody>
-          <a:bodyPr wrap="square">
-            <a:spAutoFit/>
-          </a:bodyPr>
-          <a:lstStyle/>
-          <a:p>
-            <a:pPr algn="ctr"/>
-            <a:r>
-              <a:rPr sz="1200" b="1" i="0">
-                <a:solidFill>
-                  <a:srgbClr val="0B1F3A"/>
-                </a:solidFill>
-              </a:rPr>
-              <a:t>Situação</a:t>
-            </a:r>
-          </a:p>
-        </p:txBody>
-      </p:sp>
-      <p:sp>
-        <p:nvSpPr>
-          <p:cNvPr id="24" name="Rectangle 23"/>
+            <a:off x="6492240" y="2231136"/>
+            <a:ext cx="5120640" cy="320040"/>
+          </a:xfrm>
+          <a:prstGeom prst="rect">
+            <a:avLst/>
+          </a:prstGeom>
+          <a:noFill/>
+        </p:spPr>
+        <p:txBody>
+          <a:bodyPr wrap="square">
+            <a:spAutoFit/>
+          </a:bodyPr>
+          <a:lstStyle/>
+          <a:p>
+            <a:pPr algn="l"/>
+            <a:r>
+              <a:rPr sz="1100" b="0" i="0">
+                <a:solidFill>
+                  <a:srgbClr val="CCD6E8"/>
+                </a:solidFill>
+              </a:rPr>
+              <a:t>elimina subsídios que amorteciam o PLD para</a:t>
+            </a:r>
+          </a:p>
+        </p:txBody>
+      </p:sp>
+      <p:sp>
+        <p:nvSpPr>
+          <p:cNvPr id="24" name="TextBox 23"/>
+          <p:cNvSpPr txBox="1"/>
+          <p:nvPr/>
+        </p:nvSpPr>
+        <p:spPr>
+          <a:xfrm>
+            <a:off x="6492240" y="2569463"/>
+            <a:ext cx="5120640" cy="320040"/>
+          </a:xfrm>
+          <a:prstGeom prst="rect">
+            <a:avLst/>
+          </a:prstGeom>
+          <a:noFill/>
+        </p:spPr>
+        <p:txBody>
+          <a:bodyPr wrap="square">
+            <a:spAutoFit/>
+          </a:bodyPr>
+          <a:lstStyle/>
+          <a:p>
+            <a:pPr algn="l"/>
+            <a:r>
+              <a:rPr sz="1100" b="0" i="0">
+                <a:solidFill>
+                  <a:srgbClr val="CCD6E8"/>
+                </a:solidFill>
+              </a:rPr>
+              <a:t>consumidores no mercado livre</a:t>
+            </a:r>
+          </a:p>
+        </p:txBody>
+      </p:sp>
+      <p:sp>
+        <p:nvSpPr>
+          <p:cNvPr id="25" name="TextBox 24"/>
+          <p:cNvSpPr txBox="1"/>
+          <p:nvPr/>
+        </p:nvSpPr>
+        <p:spPr>
+          <a:xfrm>
+            <a:off x="6492240" y="2907791"/>
+            <a:ext cx="5120640" cy="320040"/>
+          </a:xfrm>
+          <a:prstGeom prst="rect">
+            <a:avLst/>
+          </a:prstGeom>
+          <a:noFill/>
+        </p:spPr>
+        <p:txBody>
+          <a:bodyPr wrap="square">
+            <a:spAutoFit/>
+          </a:bodyPr>
+          <a:lstStyle/>
+          <a:p>
+            <a:pPr algn="l"/>
+            <a:r>
+              <a:rPr sz="1100" b="1" i="0">
+                <a:solidFill>
+                  <a:srgbClr val="FF8C00"/>
+                </a:solidFill>
+              </a:rPr>
+              <a:t>→ Quem já migrou paga mais AGORA</a:t>
+            </a:r>
+          </a:p>
+        </p:txBody>
+      </p:sp>
+      <p:sp>
+        <p:nvSpPr>
+          <p:cNvPr id="26" name="TextBox 25"/>
+          <p:cNvSpPr txBox="1"/>
+          <p:nvPr/>
+        </p:nvSpPr>
+        <p:spPr>
+          <a:xfrm>
+            <a:off x="6492240" y="3246120"/>
+            <a:ext cx="5120640" cy="320040"/>
+          </a:xfrm>
+          <a:prstGeom prst="rect">
+            <a:avLst/>
+          </a:prstGeom>
+          <a:noFill/>
+        </p:spPr>
+        <p:txBody>
+          <a:bodyPr wrap="square">
+            <a:spAutoFit/>
+          </a:bodyPr>
+          <a:lstStyle/>
+          <a:p>
+            <a:pPr algn="l"/>
+            <a:r>
+              <a:rPr sz="1100" b="1" i="0">
+                <a:solidFill>
+                  <a:srgbClr val="FF8C00"/>
+                </a:solidFill>
+              </a:rPr>
+              <a:t>→ Quem ainda vai migrar vê o futuro no bolso alheio</a:t>
+            </a:r>
+          </a:p>
+        </p:txBody>
+      </p:sp>
+      <p:sp>
+        <p:nvSpPr>
+          <p:cNvPr id="27" name="TextBox 26"/>
+          <p:cNvSpPr txBox="1"/>
+          <p:nvPr/>
+        </p:nvSpPr>
+        <p:spPr>
+          <a:xfrm>
+            <a:off x="6492240" y="3584448"/>
+            <a:ext cx="5120640" cy="320040"/>
+          </a:xfrm>
+          <a:prstGeom prst="rect">
+            <a:avLst/>
+          </a:prstGeom>
+          <a:noFill/>
+        </p:spPr>
+        <p:txBody>
+          <a:bodyPr wrap="square">
+            <a:spAutoFit/>
+          </a:bodyPr>
+          <a:lstStyle/>
+          <a:p>
+            <a:pPr algn="l"/>
+            <a:r>
+              <a:rPr sz="1100" b="0" i="0">
+                <a:solidFill>
+                  <a:srgbClr val="CCD6E8"/>
+                </a:solidFill>
+              </a:rPr>
+              <a:t>Repricing = urgência imediata, não só em 2028</a:t>
+            </a:r>
+          </a:p>
+        </p:txBody>
+      </p:sp>
+      <p:sp>
+        <p:nvSpPr>
+          <p:cNvPr id="28" name="Rectangle 27"/>
           <p:cNvSpPr/>
           <p:nvPr/>
         </p:nvSpPr>
         <p:spPr>
           <a:xfrm>
-            <a:off x="3383280" y="3063240"/>
-            <a:ext cx="3840480" cy="384048"/>
+            <a:off x="365760" y="3657600"/>
+            <a:ext cx="2194560" cy="384048"/>
           </a:xfrm>
           <a:prstGeom prst="rect">
             <a:avLst/>
@@ -30785,14 +30921,14 @@
       </p:sp>
       <p:sp>
         <p:nvSpPr>
-          <p:cNvPr id="25" name="TextBox 24"/>
-          <p:cNvSpPr txBox="1"/>
-          <p:nvPr/>
-        </p:nvSpPr>
-        <p:spPr>
-          <a:xfrm>
-            <a:off x="3438144" y="3118104"/>
-            <a:ext cx="3730752" cy="292607"/>
+          <p:cNvPr id="29" name="TextBox 28"/>
+          <p:cNvSpPr txBox="1"/>
+          <p:nvPr/>
+        </p:nvSpPr>
+        <p:spPr>
+          <a:xfrm>
+            <a:off x="420624" y="3712463"/>
+            <a:ext cx="2084831" cy="292607"/>
           </a:xfrm>
           <a:prstGeom prst="rect">
             <a:avLst/>
@@ -30812,21 +30948,21 @@
                   <a:srgbClr val="0B1F3A"/>
                 </a:solidFill>
               </a:rPr>
-              <a:t>No ACR (antes)</a:t>
-            </a:r>
-          </a:p>
-        </p:txBody>
-      </p:sp>
-      <p:sp>
-        <p:nvSpPr>
-          <p:cNvPr id="26" name="Rectangle 25"/>
+              <a:t>Dimensão</a:t>
+            </a:r>
+          </a:p>
+        </p:txBody>
+      </p:sp>
+      <p:sp>
+        <p:nvSpPr>
+          <p:cNvPr id="30" name="Rectangle 29"/>
           <p:cNvSpPr/>
           <p:nvPr/>
         </p:nvSpPr>
         <p:spPr>
           <a:xfrm>
-            <a:off x="7223760" y="3063240"/>
-            <a:ext cx="4480560" cy="384048"/>
+            <a:off x="2560320" y="3657600"/>
+            <a:ext cx="2286000" cy="384048"/>
           </a:xfrm>
           <a:prstGeom prst="rect">
             <a:avLst/>
@@ -30862,14 +30998,14 @@
       </p:sp>
       <p:sp>
         <p:nvSpPr>
-          <p:cNvPr id="27" name="TextBox 26"/>
-          <p:cNvSpPr txBox="1"/>
-          <p:nvPr/>
-        </p:nvSpPr>
-        <p:spPr>
-          <a:xfrm>
-            <a:off x="7278624" y="3118104"/>
-            <a:ext cx="4370832" cy="292607"/>
+          <p:cNvPr id="31" name="TextBox 30"/>
+          <p:cNvSpPr txBox="1"/>
+          <p:nvPr/>
+        </p:nvSpPr>
+        <p:spPr>
+          <a:xfrm>
+            <a:off x="2615184" y="3712463"/>
+            <a:ext cx="2176272" cy="292607"/>
           </a:xfrm>
           <a:prstGeom prst="rect">
             <a:avLst/>
@@ -30889,21 +31025,175 @@
                   <a:srgbClr val="0B1F3A"/>
                 </a:solidFill>
               </a:rPr>
-              <a:t>No ACL (após abertura)</a:t>
-            </a:r>
-          </a:p>
-        </p:txBody>
-      </p:sp>
-      <p:sp>
-        <p:nvSpPr>
-          <p:cNvPr id="28" name="Rectangle 27"/>
+              <a:t>ACR (regulado)</a:t>
+            </a:r>
+          </a:p>
+        </p:txBody>
+      </p:sp>
+      <p:sp>
+        <p:nvSpPr>
+          <p:cNvPr id="32" name="Rectangle 31"/>
           <p:cNvSpPr/>
           <p:nvPr/>
         </p:nvSpPr>
         <p:spPr>
           <a:xfrm>
-            <a:off x="457200" y="3447288"/>
-            <a:ext cx="2926080" cy="347472"/>
+            <a:off x="4846320" y="3657600"/>
+            <a:ext cx="2560320" cy="384048"/>
+          </a:xfrm>
+          <a:prstGeom prst="rect">
+            <a:avLst/>
+          </a:prstGeom>
+          <a:solidFill>
+            <a:srgbClr val="FF8C00"/>
+          </a:solidFill>
+          <a:ln>
+            <a:noFill/>
+          </a:ln>
+        </p:spPr>
+        <p:style>
+          <a:lnRef idx="1">
+            <a:schemeClr val="accent1"/>
+          </a:lnRef>
+          <a:fillRef idx="3">
+            <a:schemeClr val="accent1"/>
+          </a:fillRef>
+          <a:effectRef idx="2">
+            <a:schemeClr val="accent1"/>
+          </a:effectRef>
+          <a:fontRef idx="minor">
+            <a:schemeClr val="lt1"/>
+          </a:fontRef>
+        </p:style>
+        <p:txBody>
+          <a:bodyPr rtlCol="0" anchor="ctr"/>
+          <a:lstStyle/>
+          <a:p>
+            <a:pPr algn="ctr"/>
+          </a:p>
+        </p:txBody>
+      </p:sp>
+      <p:sp>
+        <p:nvSpPr>
+          <p:cNvPr id="33" name="TextBox 32"/>
+          <p:cNvSpPr txBox="1"/>
+          <p:nvPr/>
+        </p:nvSpPr>
+        <p:spPr>
+          <a:xfrm>
+            <a:off x="4901183" y="3712463"/>
+            <a:ext cx="2450591" cy="292607"/>
+          </a:xfrm>
+          <a:prstGeom prst="rect">
+            <a:avLst/>
+          </a:prstGeom>
+          <a:noFill/>
+        </p:spPr>
+        <p:txBody>
+          <a:bodyPr wrap="square">
+            <a:spAutoFit/>
+          </a:bodyPr>
+          <a:lstStyle/>
+          <a:p>
+            <a:pPr algn="ctr"/>
+            <a:r>
+              <a:rPr sz="1200" b="1" i="0">
+                <a:solidFill>
+                  <a:srgbClr val="0B1F3A"/>
+                </a:solidFill>
+              </a:rPr>
+              <a:t>ACL sem MP 1304</a:t>
+            </a:r>
+          </a:p>
+        </p:txBody>
+      </p:sp>
+      <p:sp>
+        <p:nvSpPr>
+          <p:cNvPr id="34" name="Rectangle 33"/>
+          <p:cNvSpPr/>
+          <p:nvPr/>
+        </p:nvSpPr>
+        <p:spPr>
+          <a:xfrm>
+            <a:off x="7406640" y="3657600"/>
+            <a:ext cx="4389120" cy="384048"/>
+          </a:xfrm>
+          <a:prstGeom prst="rect">
+            <a:avLst/>
+          </a:prstGeom>
+          <a:solidFill>
+            <a:srgbClr val="FF8C00"/>
+          </a:solidFill>
+          <a:ln>
+            <a:noFill/>
+          </a:ln>
+        </p:spPr>
+        <p:style>
+          <a:lnRef idx="1">
+            <a:schemeClr val="accent1"/>
+          </a:lnRef>
+          <a:fillRef idx="3">
+            <a:schemeClr val="accent1"/>
+          </a:fillRef>
+          <a:effectRef idx="2">
+            <a:schemeClr val="accent1"/>
+          </a:effectRef>
+          <a:fontRef idx="minor">
+            <a:schemeClr val="lt1"/>
+          </a:fontRef>
+        </p:style>
+        <p:txBody>
+          <a:bodyPr rtlCol="0" anchor="ctr"/>
+          <a:lstStyle/>
+          <a:p>
+            <a:pPr algn="ctr"/>
+          </a:p>
+        </p:txBody>
+      </p:sp>
+      <p:sp>
+        <p:nvSpPr>
+          <p:cNvPr id="35" name="TextBox 34"/>
+          <p:cNvSpPr txBox="1"/>
+          <p:nvPr/>
+        </p:nvSpPr>
+        <p:spPr>
+          <a:xfrm>
+            <a:off x="7461504" y="3712463"/>
+            <a:ext cx="4279392" cy="292607"/>
+          </a:xfrm>
+          <a:prstGeom prst="rect">
+            <a:avLst/>
+          </a:prstGeom>
+          <a:noFill/>
+        </p:spPr>
+        <p:txBody>
+          <a:bodyPr wrap="square">
+            <a:spAutoFit/>
+          </a:bodyPr>
+          <a:lstStyle/>
+          <a:p>
+            <a:pPr algn="ctr"/>
+            <a:r>
+              <a:rPr sz="1200" b="1" i="0">
+                <a:solidFill>
+                  <a:srgbClr val="0B1F3A"/>
+                </a:solidFill>
+              </a:rPr>
+              <a:t>ACL com MP 1304</a:t>
+            </a:r>
+          </a:p>
+        </p:txBody>
+      </p:sp>
+      <p:sp>
+        <p:nvSpPr>
+          <p:cNvPr id="36" name="Rectangle 35"/>
+          <p:cNvSpPr/>
+          <p:nvPr/>
+        </p:nvSpPr>
+        <p:spPr>
+          <a:xfrm>
+            <a:off x="365760" y="4041648"/>
+            <a:ext cx="2194560" cy="347472"/>
           </a:xfrm>
           <a:prstGeom prst="rect">
             <a:avLst/>
@@ -30941,14 +31231,14 @@
       </p:sp>
       <p:sp>
         <p:nvSpPr>
-          <p:cNvPr id="29" name="TextBox 28"/>
-          <p:cNvSpPr txBox="1"/>
-          <p:nvPr/>
-        </p:nvSpPr>
-        <p:spPr>
-          <a:xfrm>
-            <a:off x="512064" y="3493008"/>
-            <a:ext cx="2816352" cy="274320"/>
+          <p:cNvPr id="37" name="TextBox 36"/>
+          <p:cNvSpPr txBox="1"/>
+          <p:nvPr/>
+        </p:nvSpPr>
+        <p:spPr>
+          <a:xfrm>
+            <a:off x="420624" y="4087368"/>
+            <a:ext cx="2084831" cy="274320"/>
           </a:xfrm>
           <a:prstGeom prst="rect">
             <a:avLst/>
@@ -30968,21 +31258,21 @@
                   <a:srgbClr val="FFFFFF"/>
                 </a:solidFill>
               </a:rPr>
-              <a:t>Preço da energia</a:t>
-            </a:r>
-          </a:p>
-        </p:txBody>
-      </p:sp>
-      <p:sp>
-        <p:nvSpPr>
-          <p:cNvPr id="30" name="Rectangle 29"/>
+              <a:t>Preço base</a:t>
+            </a:r>
+          </a:p>
+        </p:txBody>
+      </p:sp>
+      <p:sp>
+        <p:nvSpPr>
+          <p:cNvPr id="38" name="Rectangle 37"/>
           <p:cNvSpPr/>
           <p:nvPr/>
         </p:nvSpPr>
         <p:spPr>
           <a:xfrm>
-            <a:off x="3383280" y="3447288"/>
-            <a:ext cx="3840480" cy="347472"/>
+            <a:off x="2560320" y="4041648"/>
+            <a:ext cx="2286000" cy="347472"/>
           </a:xfrm>
           <a:prstGeom prst="rect">
             <a:avLst/>
@@ -31020,14 +31310,14 @@
       </p:sp>
       <p:sp>
         <p:nvSpPr>
-          <p:cNvPr id="31" name="TextBox 30"/>
-          <p:cNvSpPr txBox="1"/>
-          <p:nvPr/>
-        </p:nvSpPr>
-        <p:spPr>
-          <a:xfrm>
-            <a:off x="3438144" y="3493008"/>
-            <a:ext cx="3730752" cy="274320"/>
+          <p:cNvPr id="39" name="TextBox 38"/>
+          <p:cNvSpPr txBox="1"/>
+          <p:nvPr/>
+        </p:nvSpPr>
+        <p:spPr>
+          <a:xfrm>
+            <a:off x="2615184" y="4087368"/>
+            <a:ext cx="2176272" cy="274320"/>
           </a:xfrm>
           <a:prstGeom prst="rect">
             <a:avLst/>
@@ -31047,21 +31337,21 @@
                   <a:srgbClr val="FFFFFF"/>
                 </a:solidFill>
               </a:rPr>
-              <a:t>Tarifa regulada — previsível</a:t>
-            </a:r>
-          </a:p>
-        </p:txBody>
-      </p:sp>
-      <p:sp>
-        <p:nvSpPr>
-          <p:cNvPr id="32" name="Rectangle 31"/>
+              <a:t>Tarifa regulada</a:t>
+            </a:r>
+          </a:p>
+        </p:txBody>
+      </p:sp>
+      <p:sp>
+        <p:nvSpPr>
+          <p:cNvPr id="40" name="Rectangle 39"/>
           <p:cNvSpPr/>
           <p:nvPr/>
         </p:nvSpPr>
         <p:spPr>
           <a:xfrm>
-            <a:off x="7223760" y="3447288"/>
-            <a:ext cx="4480560" cy="347472"/>
+            <a:off x="4846320" y="4041648"/>
+            <a:ext cx="2560320" cy="347472"/>
           </a:xfrm>
           <a:prstGeom prst="rect">
             <a:avLst/>
@@ -31099,14 +31389,14 @@
       </p:sp>
       <p:sp>
         <p:nvSpPr>
-          <p:cNvPr id="33" name="TextBox 32"/>
-          <p:cNvSpPr txBox="1"/>
-          <p:nvPr/>
-        </p:nvSpPr>
-        <p:spPr>
-          <a:xfrm>
-            <a:off x="7278624" y="3493008"/>
-            <a:ext cx="4370832" cy="274320"/>
+          <p:cNvPr id="41" name="TextBox 40"/>
+          <p:cNvSpPr txBox="1"/>
+          <p:nvPr/>
+        </p:nvSpPr>
+        <p:spPr>
+          <a:xfrm>
+            <a:off x="4901183" y="4087368"/>
+            <a:ext cx="2450591" cy="274320"/>
           </a:xfrm>
           <a:prstGeom prst="rect">
             <a:avLst/>
@@ -31126,27 +31416,27 @@
                   <a:srgbClr val="FFFFFF"/>
                 </a:solidFill>
               </a:rPr>
-              <a:t>Preço de mercado — variável (PLD)</a:t>
-            </a:r>
-          </a:p>
-        </p:txBody>
-      </p:sp>
-      <p:sp>
-        <p:nvSpPr>
-          <p:cNvPr id="34" name="Rectangle 33"/>
+              <a:t>PLD de mercado</a:t>
+            </a:r>
+          </a:p>
+        </p:txBody>
+      </p:sp>
+      <p:sp>
+        <p:nvSpPr>
+          <p:cNvPr id="42" name="Rectangle 41"/>
           <p:cNvSpPr/>
           <p:nvPr/>
         </p:nvSpPr>
         <p:spPr>
           <a:xfrm>
-            <a:off x="457200" y="3794760"/>
-            <a:ext cx="2926080" cy="347472"/>
-          </a:xfrm>
-          <a:prstGeom prst="rect">
-            <a:avLst/>
-          </a:prstGeom>
-          <a:solidFill>
-            <a:srgbClr val="102A50"/>
+            <a:off x="7406640" y="4041648"/>
+            <a:ext cx="4389120" cy="347472"/>
+          </a:xfrm>
+          <a:prstGeom prst="rect">
+            <a:avLst/>
+          </a:prstGeom>
+          <a:solidFill>
+            <a:srgbClr val="1E355A"/>
           </a:solidFill>
           <a:ln w="3810">
             <a:solidFill>
@@ -31178,14 +31468,14 @@
       </p:sp>
       <p:sp>
         <p:nvSpPr>
-          <p:cNvPr id="35" name="TextBox 34"/>
-          <p:cNvSpPr txBox="1"/>
-          <p:nvPr/>
-        </p:nvSpPr>
-        <p:spPr>
-          <a:xfrm>
-            <a:off x="512064" y="3840480"/>
-            <a:ext cx="2816352" cy="274320"/>
+          <p:cNvPr id="43" name="TextBox 42"/>
+          <p:cNvSpPr txBox="1"/>
+          <p:nvPr/>
+        </p:nvSpPr>
+        <p:spPr>
+          <a:xfrm>
+            <a:off x="7461504" y="4087368"/>
+            <a:ext cx="4279392" cy="274320"/>
           </a:xfrm>
           <a:prstGeom prst="rect">
             <a:avLst/>
@@ -31205,21 +31495,21 @@
                   <a:srgbClr val="FFFFFF"/>
                 </a:solidFill>
               </a:rPr>
-              <a:t>Exposição ao pico</a:t>
-            </a:r>
-          </a:p>
-        </p:txBody>
-      </p:sp>
-      <p:sp>
-        <p:nvSpPr>
-          <p:cNvPr id="36" name="Rectangle 35"/>
+              <a:t>PLD + fim de subsídios</a:t>
+            </a:r>
+          </a:p>
+        </p:txBody>
+      </p:sp>
+      <p:sp>
+        <p:nvSpPr>
+          <p:cNvPr id="44" name="Rectangle 43"/>
           <p:cNvSpPr/>
           <p:nvPr/>
         </p:nvSpPr>
         <p:spPr>
           <a:xfrm>
-            <a:off x="3383280" y="3794760"/>
-            <a:ext cx="3840480" cy="347472"/>
+            <a:off x="365760" y="4389120"/>
+            <a:ext cx="2194560" cy="347472"/>
           </a:xfrm>
           <a:prstGeom prst="rect">
             <a:avLst/>
@@ -31257,14 +31547,14 @@
       </p:sp>
       <p:sp>
         <p:nvSpPr>
-          <p:cNvPr id="37" name="TextBox 36"/>
-          <p:cNvSpPr txBox="1"/>
-          <p:nvPr/>
-        </p:nvSpPr>
-        <p:spPr>
-          <a:xfrm>
-            <a:off x="3438144" y="3840480"/>
-            <a:ext cx="3730752" cy="274320"/>
+          <p:cNvPr id="45" name="TextBox 44"/>
+          <p:cNvSpPr txBox="1"/>
+          <p:nvPr/>
+        </p:nvSpPr>
+        <p:spPr>
+          <a:xfrm>
+            <a:off x="420624" y="4434840"/>
+            <a:ext cx="2084831" cy="274320"/>
           </a:xfrm>
           <a:prstGeom prst="rect">
             <a:avLst/>
@@ -31284,21 +31574,21 @@
                   <a:srgbClr val="FFFFFF"/>
                 </a:solidFill>
               </a:rPr>
-              <a:t>Limitada pela ANEEL</a:t>
-            </a:r>
-          </a:p>
-        </p:txBody>
-      </p:sp>
-      <p:sp>
-        <p:nvSpPr>
-          <p:cNvPr id="38" name="Rectangle 37"/>
+              <a:t>Exposição ao pico</a:t>
+            </a:r>
+          </a:p>
+        </p:txBody>
+      </p:sp>
+      <p:sp>
+        <p:nvSpPr>
+          <p:cNvPr id="46" name="Rectangle 45"/>
           <p:cNvSpPr/>
           <p:nvPr/>
         </p:nvSpPr>
         <p:spPr>
           <a:xfrm>
-            <a:off x="7223760" y="3794760"/>
-            <a:ext cx="4480560" cy="347472"/>
+            <a:off x="2560320" y="4389120"/>
+            <a:ext cx="2286000" cy="347472"/>
           </a:xfrm>
           <a:prstGeom prst="rect">
             <a:avLst/>
@@ -31336,14 +31626,14 @@
       </p:sp>
       <p:sp>
         <p:nvSpPr>
-          <p:cNvPr id="39" name="TextBox 38"/>
-          <p:cNvSpPr txBox="1"/>
-          <p:nvPr/>
-        </p:nvSpPr>
-        <p:spPr>
-          <a:xfrm>
-            <a:off x="7278624" y="3840480"/>
-            <a:ext cx="4370832" cy="274320"/>
+          <p:cNvPr id="47" name="TextBox 46"/>
+          <p:cNvSpPr txBox="1"/>
+          <p:nvPr/>
+        </p:nvSpPr>
+        <p:spPr>
+          <a:xfrm>
+            <a:off x="2615184" y="4434840"/>
+            <a:ext cx="2176272" cy="274320"/>
           </a:xfrm>
           <a:prstGeom prst="rect">
             <a:avLst/>
@@ -31363,27 +31653,27 @@
                   <a:srgbClr val="FFFFFF"/>
                 </a:solidFill>
               </a:rPr>
-              <a:t>Total: paga o PLD do dia</a:t>
-            </a:r>
-          </a:p>
-        </p:txBody>
-      </p:sp>
-      <p:sp>
-        <p:nvSpPr>
-          <p:cNvPr id="40" name="Rectangle 39"/>
+              <a:t>Limitada pela ANEEL</a:t>
+            </a:r>
+          </a:p>
+        </p:txBody>
+      </p:sp>
+      <p:sp>
+        <p:nvSpPr>
+          <p:cNvPr id="48" name="Rectangle 47"/>
           <p:cNvSpPr/>
           <p:nvPr/>
         </p:nvSpPr>
         <p:spPr>
           <a:xfrm>
-            <a:off x="457200" y="4142232"/>
-            <a:ext cx="2926080" cy="347472"/>
-          </a:xfrm>
-          <a:prstGeom prst="rect">
-            <a:avLst/>
-          </a:prstGeom>
-          <a:solidFill>
-            <a:srgbClr val="1E355A"/>
+            <a:off x="4846320" y="4389120"/>
+            <a:ext cx="2560320" cy="347472"/>
+          </a:xfrm>
+          <a:prstGeom prst="rect">
+            <a:avLst/>
+          </a:prstGeom>
+          <a:solidFill>
+            <a:srgbClr val="102A50"/>
           </a:solidFill>
           <a:ln w="3810">
             <a:solidFill>
@@ -31415,14 +31705,14 @@
       </p:sp>
       <p:sp>
         <p:nvSpPr>
-          <p:cNvPr id="41" name="TextBox 40"/>
-          <p:cNvSpPr txBox="1"/>
-          <p:nvPr/>
-        </p:nvSpPr>
-        <p:spPr>
-          <a:xfrm>
-            <a:off x="512064" y="4187952"/>
-            <a:ext cx="2816352" cy="274320"/>
+          <p:cNvPr id="49" name="TextBox 48"/>
+          <p:cNvSpPr txBox="1"/>
+          <p:nvPr/>
+        </p:nvSpPr>
+        <p:spPr>
+          <a:xfrm>
+            <a:off x="4901183" y="4434840"/>
+            <a:ext cx="2450591" cy="274320"/>
           </a:xfrm>
           <a:prstGeom prst="rect">
             <a:avLst/>
@@ -31442,27 +31732,27 @@
                   <a:srgbClr val="FFFFFF"/>
                 </a:solidFill>
               </a:rPr>
-              <a:t>Impacto de seca</a:t>
-            </a:r>
-          </a:p>
-        </p:txBody>
-      </p:sp>
-      <p:sp>
-        <p:nvSpPr>
-          <p:cNvPr id="42" name="Rectangle 41"/>
+              <a:t>Total (paga PLD do dia)</a:t>
+            </a:r>
+          </a:p>
+        </p:txBody>
+      </p:sp>
+      <p:sp>
+        <p:nvSpPr>
+          <p:cNvPr id="50" name="Rectangle 49"/>
           <p:cNvSpPr/>
           <p:nvPr/>
         </p:nvSpPr>
         <p:spPr>
           <a:xfrm>
-            <a:off x="3383280" y="4142232"/>
-            <a:ext cx="3840480" cy="347472"/>
-          </a:xfrm>
-          <a:prstGeom prst="rect">
-            <a:avLst/>
-          </a:prstGeom>
-          <a:solidFill>
-            <a:srgbClr val="1E355A"/>
+            <a:off x="7406640" y="4389120"/>
+            <a:ext cx="4389120" cy="347472"/>
+          </a:xfrm>
+          <a:prstGeom prst="rect">
+            <a:avLst/>
+          </a:prstGeom>
+          <a:solidFill>
+            <a:srgbClr val="102A50"/>
           </a:solidFill>
           <a:ln w="3810">
             <a:solidFill>
@@ -31494,14 +31784,14 @@
       </p:sp>
       <p:sp>
         <p:nvSpPr>
-          <p:cNvPr id="43" name="TextBox 42"/>
-          <p:cNvSpPr txBox="1"/>
-          <p:nvPr/>
-        </p:nvSpPr>
-        <p:spPr>
-          <a:xfrm>
-            <a:off x="3438144" y="4187952"/>
-            <a:ext cx="3730752" cy="274320"/>
+          <p:cNvPr id="51" name="TextBox 50"/>
+          <p:cNvSpPr txBox="1"/>
+          <p:nvPr/>
+        </p:nvSpPr>
+        <p:spPr>
+          <a:xfrm>
+            <a:off x="7461504" y="4434840"/>
+            <a:ext cx="4279392" cy="274320"/>
           </a:xfrm>
           <a:prstGeom prst="rect">
             <a:avLst/>
@@ -31521,21 +31811,21 @@
                   <a:srgbClr val="FFFFFF"/>
                 </a:solidFill>
               </a:rPr>
-              <a:t>Amortecido</a:t>
-            </a:r>
-          </a:p>
-        </p:txBody>
-      </p:sp>
-      <p:sp>
-        <p:nvSpPr>
-          <p:cNvPr id="44" name="Rectangle 43"/>
+              <a:t>Total + maior base de custo</a:t>
+            </a:r>
+          </a:p>
+        </p:txBody>
+      </p:sp>
+      <p:sp>
+        <p:nvSpPr>
+          <p:cNvPr id="52" name="Rectangle 51"/>
           <p:cNvSpPr/>
           <p:nvPr/>
         </p:nvSpPr>
         <p:spPr>
           <a:xfrm>
-            <a:off x="7223760" y="4142232"/>
-            <a:ext cx="4480560" cy="347472"/>
+            <a:off x="365760" y="4736592"/>
+            <a:ext cx="2194560" cy="347472"/>
           </a:xfrm>
           <a:prstGeom prst="rect">
             <a:avLst/>
@@ -31573,14 +31863,14 @@
       </p:sp>
       <p:sp>
         <p:nvSpPr>
-          <p:cNvPr id="45" name="TextBox 44"/>
-          <p:cNvSpPr txBox="1"/>
-          <p:nvPr/>
-        </p:nvSpPr>
-        <p:spPr>
-          <a:xfrm>
-            <a:off x="7278624" y="4187952"/>
-            <a:ext cx="4370832" cy="274320"/>
+          <p:cNvPr id="53" name="TextBox 52"/>
+          <p:cNvSpPr txBox="1"/>
+          <p:nvPr/>
+        </p:nvSpPr>
+        <p:spPr>
+          <a:xfrm>
+            <a:off x="420624" y="4782312"/>
+            <a:ext cx="2084831" cy="274320"/>
           </a:xfrm>
           <a:prstGeom prst="rect">
             <a:avLst/>
@@ -31600,27 +31890,27 @@
                   <a:srgbClr val="FFFFFF"/>
                 </a:solidFill>
               </a:rPr>
-              <a:t>Direto no bolso</a:t>
-            </a:r>
-          </a:p>
-        </p:txBody>
-      </p:sp>
-      <p:sp>
-        <p:nvSpPr>
-          <p:cNvPr id="46" name="Rectangle 45"/>
+              <a:t>Impacto de seca</a:t>
+            </a:r>
+          </a:p>
+        </p:txBody>
+      </p:sp>
+      <p:sp>
+        <p:nvSpPr>
+          <p:cNvPr id="54" name="Rectangle 53"/>
           <p:cNvSpPr/>
           <p:nvPr/>
         </p:nvSpPr>
         <p:spPr>
           <a:xfrm>
-            <a:off x="457200" y="4489704"/>
-            <a:ext cx="2926080" cy="347472"/>
-          </a:xfrm>
-          <a:prstGeom prst="rect">
-            <a:avLst/>
-          </a:prstGeom>
-          <a:solidFill>
-            <a:srgbClr val="102A50"/>
+            <a:off x="2560320" y="4736592"/>
+            <a:ext cx="2286000" cy="347472"/>
+          </a:xfrm>
+          <a:prstGeom prst="rect">
+            <a:avLst/>
+          </a:prstGeom>
+          <a:solidFill>
+            <a:srgbClr val="1E355A"/>
           </a:solidFill>
           <a:ln w="3810">
             <a:solidFill>
@@ -31652,14 +31942,14 @@
       </p:sp>
       <p:sp>
         <p:nvSpPr>
-          <p:cNvPr id="47" name="TextBox 46"/>
-          <p:cNvSpPr txBox="1"/>
-          <p:nvPr/>
-        </p:nvSpPr>
-        <p:spPr>
-          <a:xfrm>
-            <a:off x="512064" y="4535424"/>
-            <a:ext cx="2816352" cy="274320"/>
+          <p:cNvPr id="55" name="TextBox 54"/>
+          <p:cNvSpPr txBox="1"/>
+          <p:nvPr/>
+        </p:nvSpPr>
+        <p:spPr>
+          <a:xfrm>
+            <a:off x="2615184" y="4782312"/>
+            <a:ext cx="2176272" cy="274320"/>
           </a:xfrm>
           <a:prstGeom prst="rect">
             <a:avLst/>
@@ -31679,27 +31969,27 @@
                   <a:srgbClr val="FFFFFF"/>
                 </a:solidFill>
               </a:rPr>
-              <a:t>Risco de preço</a:t>
-            </a:r>
-          </a:p>
-        </p:txBody>
-      </p:sp>
-      <p:sp>
-        <p:nvSpPr>
-          <p:cNvPr id="48" name="Rectangle 47"/>
+              <a:t>Amortecido</a:t>
+            </a:r>
+          </a:p>
+        </p:txBody>
+      </p:sp>
+      <p:sp>
+        <p:nvSpPr>
+          <p:cNvPr id="56" name="Rectangle 55"/>
           <p:cNvSpPr/>
           <p:nvPr/>
         </p:nvSpPr>
         <p:spPr>
           <a:xfrm>
-            <a:off x="3383280" y="4489704"/>
-            <a:ext cx="3840480" cy="347472"/>
-          </a:xfrm>
-          <a:prstGeom prst="rect">
-            <a:avLst/>
-          </a:prstGeom>
-          <a:solidFill>
-            <a:srgbClr val="102A50"/>
+            <a:off x="4846320" y="4736592"/>
+            <a:ext cx="2560320" cy="347472"/>
+          </a:xfrm>
+          <a:prstGeom prst="rect">
+            <a:avLst/>
+          </a:prstGeom>
+          <a:solidFill>
+            <a:srgbClr val="1E355A"/>
           </a:solidFill>
           <a:ln w="3810">
             <a:solidFill>
@@ -31731,14 +32021,14 @@
       </p:sp>
       <p:sp>
         <p:nvSpPr>
-          <p:cNvPr id="49" name="TextBox 48"/>
-          <p:cNvSpPr txBox="1"/>
-          <p:nvPr/>
-        </p:nvSpPr>
-        <p:spPr>
-          <a:xfrm>
-            <a:off x="3438144" y="4535424"/>
-            <a:ext cx="3730752" cy="274320"/>
+          <p:cNvPr id="57" name="TextBox 56"/>
+          <p:cNvSpPr txBox="1"/>
+          <p:nvPr/>
+        </p:nvSpPr>
+        <p:spPr>
+          <a:xfrm>
+            <a:off x="4901183" y="4782312"/>
+            <a:ext cx="2450591" cy="274320"/>
           </a:xfrm>
           <a:prstGeom prst="rect">
             <a:avLst/>
@@ -31758,27 +32048,27 @@
                   <a:srgbClr val="FFFFFF"/>
                 </a:solidFill>
               </a:rPr>
-              <a:t>Baixo</a:t>
-            </a:r>
-          </a:p>
-        </p:txBody>
-      </p:sp>
-      <p:sp>
-        <p:nvSpPr>
-          <p:cNvPr id="50" name="Rectangle 49"/>
+              <a:t>Direto no bolso</a:t>
+            </a:r>
+          </a:p>
+        </p:txBody>
+      </p:sp>
+      <p:sp>
+        <p:nvSpPr>
+          <p:cNvPr id="58" name="Rectangle 57"/>
           <p:cNvSpPr/>
           <p:nvPr/>
         </p:nvSpPr>
         <p:spPr>
           <a:xfrm>
-            <a:off x="7223760" y="4489704"/>
-            <a:ext cx="4480560" cy="347472"/>
-          </a:xfrm>
-          <a:prstGeom prst="rect">
-            <a:avLst/>
-          </a:prstGeom>
-          <a:solidFill>
-            <a:srgbClr val="102A50"/>
+            <a:off x="7406640" y="4736592"/>
+            <a:ext cx="4389120" cy="347472"/>
+          </a:xfrm>
+          <a:prstGeom prst="rect">
+            <a:avLst/>
+          </a:prstGeom>
+          <a:solidFill>
+            <a:srgbClr val="1E355A"/>
           </a:solidFill>
           <a:ln w="3810">
             <a:solidFill>
@@ -31810,14 +32100,14 @@
       </p:sp>
       <p:sp>
         <p:nvSpPr>
-          <p:cNvPr id="51" name="TextBox 50"/>
-          <p:cNvSpPr txBox="1"/>
-          <p:nvPr/>
-        </p:nvSpPr>
-        <p:spPr>
-          <a:xfrm>
-            <a:off x="7278624" y="4535424"/>
-            <a:ext cx="4370832" cy="274320"/>
+          <p:cNvPr id="59" name="TextBox 58"/>
+          <p:cNvSpPr txBox="1"/>
+          <p:nvPr/>
+        </p:nvSpPr>
+        <p:spPr>
+          <a:xfrm>
+            <a:off x="7461504" y="4782312"/>
+            <a:ext cx="4279392" cy="274320"/>
           </a:xfrm>
           <a:prstGeom prst="rect">
             <a:avLst/>
@@ -31837,30 +32127,32 @@
                   <a:srgbClr val="FFFFFF"/>
                 </a:solidFill>
               </a:rPr>
-              <a:t>ALTO — sem hedge = risco operacional</a:t>
-            </a:r>
-          </a:p>
-        </p:txBody>
-      </p:sp>
-      <p:sp>
-        <p:nvSpPr>
-          <p:cNvPr id="52" name="Rectangle 51"/>
+              <a:t>Direto + sem colchão regulatório</a:t>
+            </a:r>
+          </a:p>
+        </p:txBody>
+      </p:sp>
+      <p:sp>
+        <p:nvSpPr>
+          <p:cNvPr id="60" name="Rectangle 59"/>
           <p:cNvSpPr/>
           <p:nvPr/>
         </p:nvSpPr>
         <p:spPr>
           <a:xfrm>
-            <a:off x="457200" y="5989320"/>
-            <a:ext cx="11247120" cy="502920"/>
-          </a:xfrm>
-          <a:prstGeom prst="rect">
-            <a:avLst/>
-          </a:prstGeom>
-          <a:solidFill>
-            <a:srgbClr val="FF8C00"/>
-          </a:solidFill>
-          <a:ln>
-            <a:noFill/>
+            <a:off x="365760" y="5084064"/>
+            <a:ext cx="2194560" cy="347472"/>
+          </a:xfrm>
+          <a:prstGeom prst="rect">
+            <a:avLst/>
+          </a:prstGeom>
+          <a:solidFill>
+            <a:srgbClr val="102A50"/>
+          </a:solidFill>
+          <a:ln w="3810">
+            <a:solidFill>
+              <a:srgbClr val="0B1F3A"/>
+            </a:solidFill>
           </a:ln>
         </p:spPr>
         <p:style>
@@ -31887,48 +32179,48 @@
       </p:sp>
       <p:sp>
         <p:nvSpPr>
-          <p:cNvPr id="53" name="TextBox 52"/>
-          <p:cNvSpPr txBox="1"/>
-          <p:nvPr/>
-        </p:nvSpPr>
-        <p:spPr>
-          <a:xfrm>
-            <a:off x="640080" y="6035040"/>
-            <a:ext cx="10881360" cy="411480"/>
-          </a:xfrm>
-          <a:prstGeom prst="rect">
-            <a:avLst/>
-          </a:prstGeom>
-          <a:noFill/>
-        </p:spPr>
-        <p:txBody>
-          <a:bodyPr wrap="square">
-            <a:spAutoFit/>
-          </a:bodyPr>
-          <a:lstStyle/>
-          <a:p>
-            <a:pPr algn="l"/>
-            <a:r>
-              <a:rPr sz="1300" b="1" i="0">
-                <a:solidFill>
-                  <a:srgbClr val="0B1F3A"/>
-                </a:solidFill>
-              </a:rPr>
-              <a:t>◉  O Solar + BESS BOT é o hedge natural: trava o preço por 15 anos, imune ao PLD</a:t>
-            </a:r>
-          </a:p>
-        </p:txBody>
-      </p:sp>
-      <p:sp>
-        <p:nvSpPr>
-          <p:cNvPr id="54" name="Rectangle 53"/>
+          <p:cNvPr id="61" name="TextBox 60"/>
+          <p:cNvSpPr txBox="1"/>
+          <p:nvPr/>
+        </p:nvSpPr>
+        <p:spPr>
+          <a:xfrm>
+            <a:off x="420624" y="5129784"/>
+            <a:ext cx="2084831" cy="274320"/>
+          </a:xfrm>
+          <a:prstGeom prst="rect">
+            <a:avLst/>
+          </a:prstGeom>
+          <a:noFill/>
+        </p:spPr>
+        <p:txBody>
+          <a:bodyPr wrap="square">
+            <a:spAutoFit/>
+          </a:bodyPr>
+          <a:lstStyle/>
+          <a:p>
+            <a:pPr algn="ctr"/>
+            <a:r>
+              <a:rPr sz="1100" b="0" i="0">
+                <a:solidFill>
+                  <a:srgbClr val="FFFFFF"/>
+                </a:solidFill>
+              </a:rPr>
+              <a:t>Risco para empresa</a:t>
+            </a:r>
+          </a:p>
+        </p:txBody>
+      </p:sp>
+      <p:sp>
+        <p:nvSpPr>
+          <p:cNvPr id="62" name="Rectangle 61"/>
           <p:cNvSpPr/>
           <p:nvPr/>
         </p:nvSpPr>
         <p:spPr>
           <a:xfrm>
-            <a:off x="0" y="6583680"/>
-            <a:ext cx="12188952" cy="274320"/>
+            <a:off x="2560320" y="5084064"/>
+            <a:ext cx="2286000" cy="347472"/>
           </a:xfrm>
           <a:prstGeom prst="rect">
             <a:avLst/>
@@ -31936,8 +32228,10 @@
           <a:solidFill>
             <a:srgbClr val="102A50"/>
           </a:solidFill>
-          <a:ln>
-            <a:noFill/>
+          <a:ln w="3810">
+            <a:solidFill>
+              <a:srgbClr val="0B1F3A"/>
+            </a:solidFill>
           </a:ln>
         </p:spPr>
         <p:style>
@@ -31964,7 +32258,319 @@
       </p:sp>
       <p:sp>
         <p:nvSpPr>
-          <p:cNvPr id="55" name="TextBox 54"/>
+          <p:cNvPr id="63" name="TextBox 62"/>
+          <p:cNvSpPr txBox="1"/>
+          <p:nvPr/>
+        </p:nvSpPr>
+        <p:spPr>
+          <a:xfrm>
+            <a:off x="2615184" y="5129784"/>
+            <a:ext cx="2176272" cy="274320"/>
+          </a:xfrm>
+          <a:prstGeom prst="rect">
+            <a:avLst/>
+          </a:prstGeom>
+          <a:noFill/>
+        </p:spPr>
+        <p:txBody>
+          <a:bodyPr wrap="square">
+            <a:spAutoFit/>
+          </a:bodyPr>
+          <a:lstStyle/>
+          <a:p>
+            <a:pPr algn="ctr"/>
+            <a:r>
+              <a:rPr sz="1100" b="0" i="0">
+                <a:solidFill>
+                  <a:srgbClr val="FFFFFF"/>
+                </a:solidFill>
+              </a:rPr>
+              <a:t>Baixo</a:t>
+            </a:r>
+          </a:p>
+        </p:txBody>
+      </p:sp>
+      <p:sp>
+        <p:nvSpPr>
+          <p:cNvPr id="64" name="Rectangle 63"/>
+          <p:cNvSpPr/>
+          <p:nvPr/>
+        </p:nvSpPr>
+        <p:spPr>
+          <a:xfrm>
+            <a:off x="4846320" y="5084064"/>
+            <a:ext cx="2560320" cy="347472"/>
+          </a:xfrm>
+          <a:prstGeom prst="rect">
+            <a:avLst/>
+          </a:prstGeom>
+          <a:solidFill>
+            <a:srgbClr val="102A50"/>
+          </a:solidFill>
+          <a:ln w="3810">
+            <a:solidFill>
+              <a:srgbClr val="0B1F3A"/>
+            </a:solidFill>
+          </a:ln>
+        </p:spPr>
+        <p:style>
+          <a:lnRef idx="1">
+            <a:schemeClr val="accent1"/>
+          </a:lnRef>
+          <a:fillRef idx="3">
+            <a:schemeClr val="accent1"/>
+          </a:fillRef>
+          <a:effectRef idx="2">
+            <a:schemeClr val="accent1"/>
+          </a:effectRef>
+          <a:fontRef idx="minor">
+            <a:schemeClr val="lt1"/>
+          </a:fontRef>
+        </p:style>
+        <p:txBody>
+          <a:bodyPr rtlCol="0" anchor="ctr"/>
+          <a:lstStyle/>
+          <a:p>
+            <a:pPr algn="ctr"/>
+          </a:p>
+        </p:txBody>
+      </p:sp>
+      <p:sp>
+        <p:nvSpPr>
+          <p:cNvPr id="65" name="TextBox 64"/>
+          <p:cNvSpPr txBox="1"/>
+          <p:nvPr/>
+        </p:nvSpPr>
+        <p:spPr>
+          <a:xfrm>
+            <a:off x="4901183" y="5129784"/>
+            <a:ext cx="2450591" cy="274320"/>
+          </a:xfrm>
+          <a:prstGeom prst="rect">
+            <a:avLst/>
+          </a:prstGeom>
+          <a:noFill/>
+        </p:spPr>
+        <p:txBody>
+          <a:bodyPr wrap="square">
+            <a:spAutoFit/>
+          </a:bodyPr>
+          <a:lstStyle/>
+          <a:p>
+            <a:pPr algn="ctr"/>
+            <a:r>
+              <a:rPr sz="1100" b="0" i="0">
+                <a:solidFill>
+                  <a:srgbClr val="FFFFFF"/>
+                </a:solidFill>
+              </a:rPr>
+              <a:t>Alto — volátil</a:t>
+            </a:r>
+          </a:p>
+        </p:txBody>
+      </p:sp>
+      <p:sp>
+        <p:nvSpPr>
+          <p:cNvPr id="66" name="Rectangle 65"/>
+          <p:cNvSpPr/>
+          <p:nvPr/>
+        </p:nvSpPr>
+        <p:spPr>
+          <a:xfrm>
+            <a:off x="7406640" y="5084064"/>
+            <a:ext cx="4389120" cy="347472"/>
+          </a:xfrm>
+          <a:prstGeom prst="rect">
+            <a:avLst/>
+          </a:prstGeom>
+          <a:solidFill>
+            <a:srgbClr val="102A50"/>
+          </a:solidFill>
+          <a:ln w="3810">
+            <a:solidFill>
+              <a:srgbClr val="0B1F3A"/>
+            </a:solidFill>
+          </a:ln>
+        </p:spPr>
+        <p:style>
+          <a:lnRef idx="1">
+            <a:schemeClr val="accent1"/>
+          </a:lnRef>
+          <a:fillRef idx="3">
+            <a:schemeClr val="accent1"/>
+          </a:fillRef>
+          <a:effectRef idx="2">
+            <a:schemeClr val="accent1"/>
+          </a:effectRef>
+          <a:fontRef idx="minor">
+            <a:schemeClr val="lt1"/>
+          </a:fontRef>
+        </p:style>
+        <p:txBody>
+          <a:bodyPr rtlCol="0" anchor="ctr"/>
+          <a:lstStyle/>
+          <a:p>
+            <a:pPr algn="ctr"/>
+          </a:p>
+        </p:txBody>
+      </p:sp>
+      <p:sp>
+        <p:nvSpPr>
+          <p:cNvPr id="67" name="TextBox 66"/>
+          <p:cNvSpPr txBox="1"/>
+          <p:nvPr/>
+        </p:nvSpPr>
+        <p:spPr>
+          <a:xfrm>
+            <a:off x="7461504" y="5129784"/>
+            <a:ext cx="4279392" cy="274320"/>
+          </a:xfrm>
+          <a:prstGeom prst="rect">
+            <a:avLst/>
+          </a:prstGeom>
+          <a:noFill/>
+        </p:spPr>
+        <p:txBody>
+          <a:bodyPr wrap="square">
+            <a:spAutoFit/>
+          </a:bodyPr>
+          <a:lstStyle/>
+          <a:p>
+            <a:pPr algn="ctr"/>
+            <a:r>
+              <a:rPr sz="1100" b="0" i="0">
+                <a:solidFill>
+                  <a:srgbClr val="FFFFFF"/>
+                </a:solidFill>
+              </a:rPr>
+              <a:t>CRÍTICO — repricing estrutural</a:t>
+            </a:r>
+          </a:p>
+        </p:txBody>
+      </p:sp>
+      <p:sp>
+        <p:nvSpPr>
+          <p:cNvPr id="68" name="Rectangle 67"/>
+          <p:cNvSpPr/>
+          <p:nvPr/>
+        </p:nvSpPr>
+        <p:spPr>
+          <a:xfrm>
+            <a:off x="365760" y="5989320"/>
+            <a:ext cx="11430000" cy="502920"/>
+          </a:xfrm>
+          <a:prstGeom prst="rect">
+            <a:avLst/>
+          </a:prstGeom>
+          <a:solidFill>
+            <a:srgbClr val="FF8C00"/>
+          </a:solidFill>
+          <a:ln>
+            <a:noFill/>
+          </a:ln>
+        </p:spPr>
+        <p:style>
+          <a:lnRef idx="1">
+            <a:schemeClr val="accent1"/>
+          </a:lnRef>
+          <a:fillRef idx="3">
+            <a:schemeClr val="accent1"/>
+          </a:fillRef>
+          <a:effectRef idx="2">
+            <a:schemeClr val="accent1"/>
+          </a:effectRef>
+          <a:fontRef idx="minor">
+            <a:schemeClr val="lt1"/>
+          </a:fontRef>
+        </p:style>
+        <p:txBody>
+          <a:bodyPr rtlCol="0" anchor="ctr"/>
+          <a:lstStyle/>
+          <a:p>
+            <a:pPr algn="ctr"/>
+          </a:p>
+        </p:txBody>
+      </p:sp>
+      <p:sp>
+        <p:nvSpPr>
+          <p:cNvPr id="69" name="TextBox 68"/>
+          <p:cNvSpPr txBox="1"/>
+          <p:nvPr/>
+        </p:nvSpPr>
+        <p:spPr>
+          <a:xfrm>
+            <a:off x="548640" y="6035040"/>
+            <a:ext cx="11064240" cy="411480"/>
+          </a:xfrm>
+          <a:prstGeom prst="rect">
+            <a:avLst/>
+          </a:prstGeom>
+          <a:noFill/>
+        </p:spPr>
+        <p:txBody>
+          <a:bodyPr wrap="square">
+            <a:spAutoFit/>
+          </a:bodyPr>
+          <a:lstStyle/>
+          <a:p>
+            <a:pPr algn="l"/>
+            <a:r>
+              <a:rPr sz="1200" b="1" i="0">
+                <a:solidFill>
+                  <a:srgbClr val="0B1F3A"/>
+                </a:solidFill>
+              </a:rPr>
+              <a:t>◉  Solar + BESS BOT: contrato de 15 anos com tarifa travada = proteção total contra migração compulsória E repricing do MP 1304</a:t>
+            </a:r>
+          </a:p>
+        </p:txBody>
+      </p:sp>
+      <p:sp>
+        <p:nvSpPr>
+          <p:cNvPr id="70" name="Rectangle 69"/>
+          <p:cNvSpPr/>
+          <p:nvPr/>
+        </p:nvSpPr>
+        <p:spPr>
+          <a:xfrm>
+            <a:off x="0" y="6583680"/>
+            <a:ext cx="12188952" cy="274320"/>
+          </a:xfrm>
+          <a:prstGeom prst="rect">
+            <a:avLst/>
+          </a:prstGeom>
+          <a:solidFill>
+            <a:srgbClr val="102A50"/>
+          </a:solidFill>
+          <a:ln>
+            <a:noFill/>
+          </a:ln>
+        </p:spPr>
+        <p:style>
+          <a:lnRef idx="1">
+            <a:schemeClr val="accent1"/>
+          </a:lnRef>
+          <a:fillRef idx="3">
+            <a:schemeClr val="accent1"/>
+          </a:fillRef>
+          <a:effectRef idx="2">
+            <a:schemeClr val="accent1"/>
+          </a:effectRef>
+          <a:fontRef idx="minor">
+            <a:schemeClr val="lt1"/>
+          </a:fontRef>
+        </p:style>
+        <p:txBody>
+          <a:bodyPr rtlCol="0" anchor="ctr"/>
+          <a:lstStyle/>
+          <a:p>
+            <a:pPr algn="ctr"/>
+          </a:p>
+        </p:txBody>
+      </p:sp>
+      <p:sp>
+        <p:nvSpPr>
+          <p:cNvPr id="71" name="TextBox 70"/>
           <p:cNvSpPr txBox="1"/>
           <p:nvPr/>
         </p:nvSpPr>
@@ -35528,7 +36134,7 @@
         <p:spPr>
           <a:xfrm>
             <a:off x="365760" y="4709160"/>
-            <a:ext cx="11430000" cy="731520"/>
+            <a:ext cx="11430000" cy="1508760"/>
           </a:xfrm>
           <a:prstGeom prst="rect">
             <a:avLst/>
@@ -35606,7 +36212,7 @@
         </p:nvSpPr>
         <p:spPr>
           <a:xfrm>
-            <a:off x="640080" y="5074920"/>
+            <a:off x="640080" y="5102352"/>
             <a:ext cx="10972800" cy="320040"/>
           </a:xfrm>
           <a:prstGeom prst="rect">
@@ -35627,14 +36233,82 @@
                   <a:srgbClr val="FF8C00"/>
                 </a:solidFill>
               </a:rPr>
-              <a:t>Vendemos certeza de preço num mercado que vai perder essa certeza."</a:t>
-            </a:r>
-          </a:p>
-        </p:txBody>
-      </p:sp>
-      <p:sp>
-        <p:nvSpPr>
-          <p:cNvPr id="35" name="Rectangle 34"/>
+              <a:t>Vendemos certeza de preço num mercado que já perdeu essa certeza — e vai piorar."</a:t>
+            </a:r>
+          </a:p>
+        </p:txBody>
+      </p:sp>
+      <p:sp>
+        <p:nvSpPr>
+          <p:cNvPr id="35" name="TextBox 34"/>
+          <p:cNvSpPr txBox="1"/>
+          <p:nvPr/>
+        </p:nvSpPr>
+        <p:spPr>
+          <a:xfrm>
+            <a:off x="640080" y="5468112"/>
+            <a:ext cx="10972800" cy="320040"/>
+          </a:xfrm>
+          <a:prstGeom prst="rect">
+            <a:avLst/>
+          </a:prstGeom>
+          <a:noFill/>
+        </p:spPr>
+        <p:txBody>
+          <a:bodyPr wrap="square">
+            <a:spAutoFit/>
+          </a:bodyPr>
+          <a:lstStyle/>
+          <a:p>
+            <a:pPr algn="l"/>
+            <a:r>
+              <a:rPr sz="1200" b="0" i="0">
+                <a:solidFill>
+                  <a:srgbClr val="CCD6E8"/>
+                </a:solidFill>
+              </a:rPr>
+              <a:t>MP 1304 + migração compulsória ACL + boom de data centers = três forças simultâneas pressionando o preço para cima.</a:t>
+            </a:r>
+          </a:p>
+        </p:txBody>
+      </p:sp>
+      <p:sp>
+        <p:nvSpPr>
+          <p:cNvPr id="36" name="TextBox 35"/>
+          <p:cNvSpPr txBox="1"/>
+          <p:nvPr/>
+        </p:nvSpPr>
+        <p:spPr>
+          <a:xfrm>
+            <a:off x="640080" y="5833872"/>
+            <a:ext cx="10972800" cy="320040"/>
+          </a:xfrm>
+          <a:prstGeom prst="rect">
+            <a:avLst/>
+          </a:prstGeom>
+          <a:noFill/>
+        </p:spPr>
+        <p:txBody>
+          <a:bodyPr wrap="square">
+            <a:spAutoFit/>
+          </a:bodyPr>
+          <a:lstStyle/>
+          <a:p>
+            <a:pPr algn="l"/>
+            <a:r>
+              <a:rPr sz="1200" b="1" i="0">
+                <a:solidFill>
+                  <a:srgbClr val="FFD600"/>
+                </a:solidFill>
+              </a:rPr>
+              <a:t>O cliente que assina o BOT hoje compra 15 anos de imunidade a esse cenário.</a:t>
+            </a:r>
+          </a:p>
+        </p:txBody>
+      </p:sp>
+      <p:sp>
+        <p:nvSpPr>
+          <p:cNvPr id="37" name="Rectangle 36"/>
           <p:cNvSpPr/>
           <p:nvPr/>
         </p:nvSpPr>
@@ -35677,7 +36351,7 @@
       </p:sp>
       <p:sp>
         <p:nvSpPr>
-          <p:cNvPr id="36" name="TextBox 35"/>
+          <p:cNvPr id="38" name="TextBox 37"/>
           <p:cNvSpPr txBox="1"/>
           <p:nvPr/>
         </p:nvSpPr>
@@ -37550,7 +38224,7 @@
                   <a:srgbClr val="00C8FF"/>
                 </a:solidFill>
               </a:rPr>
-              <a:t>ACL 2028:</a:t>
+              <a:t>MP 1304:</a:t>
             </a:r>
           </a:p>
         </p:txBody>
@@ -37584,7 +38258,7 @@
                   <a:srgbClr val="CCD6E8"/>
                 </a:solidFill>
               </a:rPr>
-              <a:t>300.000 empresas buscam hedge de preço</a:t>
+              <a:t>Repricing imediato no ACL — quem migrou paga mais agora</a:t>
             </a:r>
           </a:p>
         </p:txBody>
@@ -37618,7 +38292,7 @@
                   <a:srgbClr val="00C8FF"/>
                 </a:solidFill>
               </a:rPr>
-              <a:t>Data Centers:</a:t>
+              <a:t>ACL 2028:</a:t>
             </a:r>
           </a:p>
         </p:txBody>
@@ -37652,7 +38326,7 @@
                   <a:srgbClr val="CCD6E8"/>
                 </a:solidFill>
               </a:rPr>
-              <a:t>R$ 150B+ → +15–25 TWh extras na rede</a:t>
+              <a:t>300.000 empresas migram compulsoriamente — hedge urgente</a:t>
             </a:r>
           </a:p>
         </p:txBody>
@@ -37686,7 +38360,7 @@
                   <a:srgbClr val="00C8FF"/>
                 </a:solidFill>
               </a:rPr>
-              <a:t>Marco Legal GD:</a:t>
+              <a:t>Data Centers:</a:t>
             </a:r>
           </a:p>
         </p:txBody>
@@ -37720,7 +38394,7 @@
                   <a:srgbClr val="CCD6E8"/>
                 </a:solidFill>
               </a:rPr>
-              <a:t>Lei 14.300/2022 — estabilidade 25 anos</a:t>
+              <a:t>R$ 150B+ → +15–25 TWh extras de demanda na rede</a:t>
             </a:r>
           </a:p>
         </p:txBody>
@@ -37754,7 +38428,7 @@
                   <a:srgbClr val="00C8FF"/>
                 </a:solidFill>
               </a:rPr>
-              <a:t>Custo BESS:</a:t>
+              <a:t>Marco Legal GD:</a:t>
             </a:r>
           </a:p>
         </p:txBody>
@@ -37788,7 +38462,7 @@
                   <a:srgbClr val="CCD6E8"/>
                 </a:solidFill>
               </a:rPr>
-              <a:t>–15%/ano → instalar hoje = melhor spread</a:t>
+              <a:t>Lei 14.300/2022 — estabilidade jurídica de 25 anos</a:t>
             </a:r>
           </a:p>
         </p:txBody>
@@ -37822,7 +38496,7 @@
                   <a:srgbClr val="00C8FF"/>
                 </a:solidFill>
               </a:rPr>
-              <a:t>ESG corporativo:</a:t>
+              <a:t>Custo BESS:</a:t>
             </a:r>
           </a:p>
         </p:txBody>
@@ -37856,7 +38530,7 @@
                   <a:srgbClr val="CCD6E8"/>
                 </a:solidFill>
               </a:rPr>
-              <a:t>Meta 100% renováveis até 2030</a:t>
+              <a:t>–15%/ano → instalar hoje = melhor spread histórico</a:t>
             </a:r>
           </a:p>
         </p:txBody>
@@ -37890,7 +38564,7 @@
                   <a:srgbClr val="00C8FF"/>
                 </a:solidFill>
               </a:rPr>
-              <a:t>ANEEL BESS:</a:t>
+              <a:t>ESG corporativo:</a:t>
             </a:r>
           </a:p>
         </p:txBody>
@@ -37924,7 +38598,7 @@
                   <a:srgbClr val="CCD6E8"/>
                 </a:solidFill>
               </a:rPr>
-              <a:t>Regulação em consolidação — janela first-mover</a:t>
+              <a:t>Meta 100% renováveis até 2030 — DCs como clientes</a:t>
             </a:r>
           </a:p>
         </p:txBody>

</xml_diff>

<commit_message>
docs: pitch deck v3.2 — correct data center energy impact units and percentage
</commit_message>
<xml_diff>
--- a/docs/Solar_BESS_Platform_PitchDeck.pptx
+++ b/docs/Solar_BESS_Platform_PitchDeck.pptx
@@ -29623,7 +29623,7 @@
                   <a:srgbClr val="CCD6E8"/>
                 </a:solidFill>
               </a:rPr>
-              <a:t>▸  +15 a 25 TWh extras de demanda na rede</a:t>
+              <a:t>▸  +2–3 GW de nova capacidade → +15–25 TWh/ano (+2,5–4% do consumo BR)*</a:t>
             </a:r>
           </a:p>
         </p:txBody>
@@ -34543,7 +34543,7 @@
                   <a:srgbClr val="FFFFFF"/>
                 </a:solidFill>
               </a:rPr>
-              <a:t>1 DC médio = 50–200 MW contínuos</a:t>
+              <a:t>1 DC médio = 50–200 MW de potência contínua</a:t>
             </a:r>
           </a:p>
         </p:txBody>
@@ -34577,7 +34577,7 @@
                   <a:srgbClr val="FFFFFF"/>
                 </a:solidFill>
               </a:rPr>
-              <a:t>Expansão 2024–2030 = +15–25 TWh/ano</a:t>
+              <a:t>Expansão 2024–2030: +2–3 GW de nova capacidade</a:t>
             </a:r>
           </a:p>
         </p:txBody>
@@ -34611,7 +34611,7 @@
                   <a:srgbClr val="FFFFFF"/>
                 </a:solidFill>
               </a:rPr>
-              <a:t>= +5–12% da capacidade total do Brasil</a:t>
+              <a:t>= +15–25 TWh/ano de consumo adicional</a:t>
             </a:r>
           </a:p>
         </p:txBody>
@@ -34642,10 +34642,10 @@
             <a:r>
               <a:rPr sz="1200" b="0" i="0">
                 <a:solidFill>
-                  <a:srgbClr val="FF8C00"/>
-                </a:solidFill>
-              </a:rPr>
-              <a:t>Rede de distribuição NÃO acompanha</a:t>
+                  <a:srgbClr val="FFFFFF"/>
+                </a:solidFill>
+              </a:rPr>
+              <a:t>= +2,5–4% do consumo elétrico anual do Brasil*</a:t>
             </a:r>
           </a:p>
         </p:txBody>
@@ -34679,14 +34679,82 @@
                   <a:srgbClr val="FF8C00"/>
                 </a:solidFill>
               </a:rPr>
-              <a:t>→ Escassez + filas de conexão + preços ↑</a:t>
-            </a:r>
-          </a:p>
-        </p:txBody>
-      </p:sp>
-      <p:sp>
-        <p:nvSpPr>
-          <p:cNvPr id="55" name="Rectangle 54"/>
+              <a:t>Rede de distribuição NÃO acompanha esse ritmo</a:t>
+            </a:r>
+          </a:p>
+        </p:txBody>
+      </p:sp>
+      <p:sp>
+        <p:nvSpPr>
+          <p:cNvPr id="55" name="TextBox 54"/>
+          <p:cNvSpPr txBox="1"/>
+          <p:nvPr/>
+        </p:nvSpPr>
+        <p:spPr>
+          <a:xfrm>
+            <a:off x="7223760" y="4846320"/>
+            <a:ext cx="4297680" cy="502920"/>
+          </a:xfrm>
+          <a:prstGeom prst="rect">
+            <a:avLst/>
+          </a:prstGeom>
+          <a:noFill/>
+        </p:spPr>
+        <p:txBody>
+          <a:bodyPr wrap="square">
+            <a:spAutoFit/>
+          </a:bodyPr>
+          <a:lstStyle/>
+          <a:p>
+            <a:pPr algn="l"/>
+            <a:r>
+              <a:rPr sz="1200" b="0" i="0">
+                <a:solidFill>
+                  <a:srgbClr val="FF8C00"/>
+                </a:solidFill>
+              </a:rPr>
+              <a:t>→ Escassez localizada + filas + preços ↑</a:t>
+            </a:r>
+          </a:p>
+        </p:txBody>
+      </p:sp>
+      <p:sp>
+        <p:nvSpPr>
+          <p:cNvPr id="56" name="TextBox 55"/>
+          <p:cNvSpPr txBox="1"/>
+          <p:nvPr/>
+        </p:nvSpPr>
+        <p:spPr>
+          <a:xfrm>
+            <a:off x="7223760" y="5486400"/>
+            <a:ext cx="4297680" cy="347472"/>
+          </a:xfrm>
+          <a:prstGeom prst="rect">
+            <a:avLst/>
+          </a:prstGeom>
+          <a:noFill/>
+        </p:spPr>
+        <p:txBody>
+          <a:bodyPr wrap="square">
+            <a:spAutoFit/>
+          </a:bodyPr>
+          <a:lstStyle/>
+          <a:p>
+            <a:pPr algn="l"/>
+            <a:r>
+              <a:rPr sz="900" b="0" i="1">
+                <a:solidFill>
+                  <a:srgbClr val="8AA0C0"/>
+                </a:solidFill>
+              </a:rPr>
+              <a:t>* Estimativa: 2–3 GW × 8.760h × 85% util. = 15–22 TWh/ano  |  Verificar: EPE — Plano Decenal de Energia</a:t>
+            </a:r>
+          </a:p>
+        </p:txBody>
+      </p:sp>
+      <p:sp>
+        <p:nvSpPr>
+          <p:cNvPr id="57" name="Rectangle 56"/>
           <p:cNvSpPr/>
           <p:nvPr/>
         </p:nvSpPr>
@@ -34731,7 +34799,7 @@
       </p:sp>
       <p:sp>
         <p:nvSpPr>
-          <p:cNvPr id="56" name="TextBox 55"/>
+          <p:cNvPr id="58" name="TextBox 57"/>
           <p:cNvSpPr txBox="1"/>
           <p:nvPr/>
         </p:nvSpPr>
@@ -34765,7 +34833,7 @@
       </p:sp>
       <p:sp>
         <p:nvSpPr>
-          <p:cNvPr id="57" name="TextBox 56"/>
+          <p:cNvPr id="59" name="TextBox 58"/>
           <p:cNvSpPr txBox="1"/>
           <p:nvPr/>
         </p:nvSpPr>
@@ -34801,7 +34869,7 @@
       </p:sp>
       <p:sp>
         <p:nvSpPr>
-          <p:cNvPr id="58" name="Rectangle 57"/>
+          <p:cNvPr id="60" name="Rectangle 59"/>
           <p:cNvSpPr/>
           <p:nvPr/>
         </p:nvSpPr>
@@ -34844,7 +34912,7 @@
       </p:sp>
       <p:sp>
         <p:nvSpPr>
-          <p:cNvPr id="59" name="TextBox 58"/>
+          <p:cNvPr id="61" name="TextBox 60"/>
           <p:cNvSpPr txBox="1"/>
           <p:nvPr/>
         </p:nvSpPr>
@@ -34878,7 +34946,7 @@
       </p:sp>
       <p:sp>
         <p:nvSpPr>
-          <p:cNvPr id="60" name="Rectangle 59"/>
+          <p:cNvPr id="62" name="Rectangle 61"/>
           <p:cNvSpPr/>
           <p:nvPr/>
         </p:nvSpPr>
@@ -34921,7 +34989,7 @@
       </p:sp>
       <p:sp>
         <p:nvSpPr>
-          <p:cNvPr id="61" name="TextBox 60"/>
+          <p:cNvPr id="63" name="TextBox 62"/>
           <p:cNvSpPr txBox="1"/>
           <p:nvPr/>
         </p:nvSpPr>
@@ -36119,8 +36187,8 @@
                   <a:srgbClr val="CCD6E8"/>
                 </a:solidFill>
               </a:rPr>
-              <a:t>+15–25 TWh/ano
-na rede</a:t>
+              <a:t>+2–3 GW instalados
++2,5–4% consumo BR*</a:t>
             </a:r>
           </a:p>
         </p:txBody>
@@ -38394,7 +38462,7 @@
                   <a:srgbClr val="CCD6E8"/>
                 </a:solidFill>
               </a:rPr>
-              <a:t>R$ 150B+ → +15–25 TWh extras de demanda na rede</a:t>
+              <a:t>R$ 150B+ → +2–3 GW instalados → +2,5–4% do consumo anual BR*</a:t>
             </a:r>
           </a:p>
         </p:txBody>

</xml_diff>